<commit_message>
Form 3 L7-L13: revise to the validated model
Co-Authored-By: Claude Opus 5.5 <noreply@anthropic.com>
Claude-Session: https://claude.ai/code/session_0115LFSb2ktGLWPeVksFkSer
</commit_message>
<xml_diff>
--- a/lecons/F3/10_FORM4_LESSON07_Internal_Structure_of_the_Earth.pptx
+++ b/lecons/F3/10_FORM4_LESSON07_Internal_Structure_of_the_Earth.pptx
@@ -50,9 +50,13 @@
     <p:sldId id="298" r:id="rId44"/>
     <p:sldId id="299" r:id="rId45"/>
     <p:sldId id="300" r:id="rId46"/>
+    <p:sldId id="301" r:id="rId47"/>
+    <p:sldId id="302" r:id="rId48"/>
+    <p:sldId id="303" r:id="rId49"/>
+    <p:sldId id="304" r:id="rId50"/>
   </p:sldIdLst>
   <p:notesMasterIdLst>
-    <p:notesMasterId r:id="rId47"/>
+    <p:notesMasterId r:id="rId51"/>
   </p:notesMasterIdLst>
   <p:sldSz cx="12192000" cy="6858000"/>
   <p:notesSz cx="6858000" cy="12192000"/>
@@ -634,7 +638,7 @@
           <a:p>
             <a:r>
               <a:rPr lang="en-US" dirty="0"/>
-              <a:t>Listen carefully to this situation from real life. Workers dig a deep well in Garoua. First they dig through red soil. Then they reach very hard rock. Amadou wonders what they would find if they could dig to the centre of the Earth. Think about it, because I am going to ask you some questions.</a:t>
+              <a:t>Listen carefully to this situation from real life. Workers dig a deep well in Garoua. First they dig through red soil, then they reach very hard rock and must stop. Amadou asks: "What would we find if we could dig down to the centre of the Earth?" Think about it, because I am going to ask you some questions.</a:t>
             </a:r>
             <a:endParaRPr lang="en-US" dirty="0"/>
           </a:p>
@@ -810,7 +814,7 @@
           <a:p>
             <a:r>
               <a:rPr lang="en-US" dirty="0"/>
-              <a:t>Good. Amadou does not know what is inside the Earth.</a:t>
+              <a:t>Good. Amadou does not know what is inside the Earth, under the rock.</a:t>
             </a:r>
             <a:endParaRPr lang="en-US" dirty="0"/>
           </a:p>
@@ -1162,7 +1166,7 @@
           <a:p>
             <a:r>
               <a:rPr lang="en-US" dirty="0"/>
-              <a:t>Good. No. It is too deep and too hot.</a:t>
+              <a:t>Good. No: it is about 6,370 km deep and far too hot.</a:t>
             </a:r>
             <a:endParaRPr lang="en-US" dirty="0"/>
           </a:p>
@@ -1426,7 +1430,7 @@
           <a:p>
             <a:r>
               <a:rPr lang="en-US" dirty="0"/>
-              <a:t>Activity 1. Look carefully at this picture: people dig a big pit in the ground. Observe every detail before I ask the question.</a:t>
+              <a:t>Activity 1. Look carefully at this diagram: the layers of the Earth. Observe every detail before I ask the question.</a:t>
             </a:r>
             <a:endParaRPr lang="en-US" dirty="0"/>
           </a:p>
@@ -1602,7 +1606,7 @@
           <a:p>
             <a:r>
               <a:rPr lang="en-US" dirty="0"/>
-              <a:t>Here is the question for Activity 1: When we dig, which layer of the Earth do we reach? Take one minute to think and write your answer in your rough notebook.</a:t>
+              <a:t>Here is the question for Activity 1: How many main layers does the Earth have? Take one minute to think and write your answer in your rough notebook.</a:t>
             </a:r>
             <a:endParaRPr lang="en-US" dirty="0"/>
           </a:p>
@@ -1690,7 +1694,7 @@
           <a:p>
             <a:r>
               <a:rPr lang="en-US" dirty="0"/>
-              <a:t>Let us check the answer together. Only the crust, the thin outer layer.</a:t>
+              <a:t>Let us check the answer together. Four: crust, mantle, outer core and inner core.</a:t>
             </a:r>
             <a:endParaRPr lang="en-US" dirty="0"/>
           </a:p>
@@ -1778,7 +1782,7 @@
           <a:p>
             <a:r>
               <a:rPr lang="en-US" dirty="0"/>
-              <a:t>Activity 2. Look carefully at this diagram: the layers of the Earth. Observe every detail before I ask the question.</a:t>
+              <a:t>Here is the next question: Which layer is in the centre? Take one minute to think and write your answer in your rough notebook.</a:t>
             </a:r>
             <a:endParaRPr lang="en-US" dirty="0"/>
           </a:p>
@@ -1866,7 +1870,7 @@
           <a:p>
             <a:r>
               <a:rPr lang="en-US" dirty="0"/>
-              <a:t>Here is the question for Activity 2: Name the four layers from the outside to the centre. Take one minute to think and write your answer in your rough notebook.</a:t>
+              <a:t>Let us check the answer together. The inner core.</a:t>
             </a:r>
             <a:endParaRPr lang="en-US" dirty="0"/>
           </a:p>
@@ -1954,7 +1958,7 @@
           <a:p>
             <a:r>
               <a:rPr lang="en-US" dirty="0"/>
-              <a:t>Let us check the answer together. Crust, mantle, outer core and inner core.</a:t>
+              <a:t>Activity 2. Look carefully at this picture: people dig a big pit in the ground. Observe every detail before I ask the question.</a:t>
             </a:r>
             <a:endParaRPr lang="en-US" dirty="0"/>
           </a:p>
@@ -2042,7 +2046,7 @@
           <a:p>
             <a:r>
               <a:rPr lang="en-US" dirty="0"/>
-              <a:t>Activity 3. Look carefully at this animation: animation: a journey to the centre of the Earth. Watch the animation to the end; it will play again.</a:t>
+              <a:t>Here is the question for Activity 2: When we dig a well, which layer of the Earth do we reach? Take one minute to think and write your answer in your rough notebook.</a:t>
             </a:r>
             <a:endParaRPr lang="en-US" dirty="0"/>
           </a:p>
@@ -2130,7 +2134,7 @@
           <a:p>
             <a:r>
               <a:rPr lang="en-US" dirty="0"/>
-              <a:t>Here is the question for Activity 3: What happens to the temperature as we go deeper? Take one minute to think and write your answer in your rough notebook.</a:t>
+              <a:t>Let us check the answer together. Only the crust, the thin outer layer.</a:t>
             </a:r>
             <a:endParaRPr lang="en-US" dirty="0"/>
           </a:p>
@@ -2218,7 +2222,7 @@
           <a:p>
             <a:r>
               <a:rPr lang="en-US" dirty="0"/>
-              <a:t>Let us check the answer together. It rises: about 6,000 °C at the centre.</a:t>
+              <a:t>Activity 3. Look carefully at this animation: animation: a journey to the centre of the Earth. Watch the animation to the end; it will play again.</a:t>
             </a:r>
             <a:endParaRPr lang="en-US" dirty="0"/>
           </a:p>
@@ -2306,7 +2310,7 @@
           <a:p>
             <a:r>
               <a:rPr lang="en-US" dirty="0"/>
-              <a:t>Now we are going to copy the board summary. Write the title and the headings neatly in your notebooks. I will give you enough time for each slide, so do not rush.</a:t>
+              <a:t>Here is the question for Activity 3: What happens to the temperature as we go deeper into the Earth? Take one minute to think and write your answer in your rough notebook.</a:t>
             </a:r>
             <a:endParaRPr lang="en-US" dirty="0"/>
           </a:p>
@@ -2394,7 +2398,7 @@
           <a:p>
             <a:r>
               <a:rPr lang="en-US" dirty="0"/>
-              <a:t>Let us copy Illustration of the Structure of the Earth. The structure of the Earth can be illustrated as follows. On this slide we have Circular view. Write each point on a new line, with the key term first, and explain it in your own words when we revise. When you finish, we go to the next slide.</a:t>
+              <a:t>Let us check the answer together. It rises, to about 6,000 °C at the centre.</a:t>
             </a:r>
             <a:endParaRPr lang="en-US" dirty="0"/>
           </a:p>
@@ -2570,7 +2574,7 @@
           <a:p>
             <a:r>
               <a:rPr lang="en-US" dirty="0"/>
-              <a:t>We continue with Illustration of the Structure of the Earth. On this slide we have Cross-sectional view. Write each point on a new line, with the key term first, and explain it in your own words when we revise.</a:t>
+              <a:t>Now we are going to copy the board summary. Write the title and the headings neatly in your notebooks. I will give you enough time for each slide, so do not rush.</a:t>
             </a:r>
             <a:endParaRPr lang="en-US" dirty="0"/>
           </a:p>
@@ -2658,7 +2662,7 @@
           <a:p>
             <a:r>
               <a:rPr lang="en-US" dirty="0"/>
-              <a:t>Now draw this illustration in your notebook: the layers of the Earth. Give it a title and label it clearly.</a:t>
+              <a:t>Let us copy the definitions. The key terms of this lesson are defined as follows. On this slide we have Crust and Mantle. Write each point on a new line, with the key term first, and explain it in your own words when we revise. When you finish, we go to the next slide.</a:t>
             </a:r>
             <a:endParaRPr lang="en-US" dirty="0"/>
           </a:p>
@@ -2746,7 +2750,7 @@
           <a:p>
             <a:r>
               <a:rPr lang="en-US" dirty="0"/>
-              <a:t>Let us copy The Main Layers. The main layers of the Earth are described as follows. On this slide we have Crust and Mantle. Write each point on a new line, with the key term first, and explain it in your own words when we revise. When you finish, we go to the next slide.</a:t>
+              <a:t>We continue with the definitions. On this slide we have Core. Write each point on a new line, with the key term first, and explain it in your own words when we revise.</a:t>
             </a:r>
             <a:endParaRPr lang="en-US" dirty="0"/>
           </a:p>
@@ -2834,7 +2838,7 @@
           <a:p>
             <a:r>
               <a:rPr lang="en-US" dirty="0"/>
-              <a:t>We continue with The Main Layers. On this slide we have Outer core and Inner core. Write each point on a new line, with the key term first, and explain it in your own words when we revise.</a:t>
+              <a:t>Let us copy Illustrations of the Structure of the Earth. The structure of the Earth is illustrated in two ways. Copy the point on Circular view on the left, then draw the diagram on the right: the layers of the Earth (circular view). Give it a title and label it clearly.</a:t>
             </a:r>
             <a:endParaRPr lang="en-US" dirty="0"/>
           </a:p>
@@ -2922,7 +2926,7 @@
           <a:p>
             <a:r>
               <a:rPr lang="en-US" dirty="0"/>
-              <a:t>Now let us check what you have understood. Question 1: Name the layer on which we live. Answer in your exercise book.</a:t>
+              <a:t>Copy the point on Cross-sectional view on the left, then draw the diagram on the right: the internal structure of the Earth (cross-section). Give it a title and label it clearly.</a:t>
             </a:r>
             <a:endParaRPr lang="en-US" dirty="0"/>
           </a:p>
@@ -3010,7 +3014,7 @@
           <a:p>
             <a:r>
               <a:rPr lang="en-US" dirty="0"/>
-              <a:t>The expected answer is: the crust. If you got it right, well done.</a:t>
+              <a:t>Let us copy Brief Description of the Main Layers. The main layers of the Earth are described as follows. On this slide we have The crust. Write each point on a new line, with the key term first, and explain it in your own words when we revise. When you finish, we go to the next slide.</a:t>
             </a:r>
             <a:endParaRPr lang="en-US" dirty="0"/>
           </a:p>
@@ -3098,7 +3102,7 @@
           <a:p>
             <a:r>
               <a:rPr lang="en-US" dirty="0"/>
-              <a:t>Now let us check what you have understood. Question 2: Why is the inner core solid though it is very hot? Answer in your exercise book.</a:t>
+              <a:t>We continue with Brief Description of the Main Layers. On this slide we have The mantle and The outer core. Write each point on a new line, with the key term first, and explain it in your own words when we revise.</a:t>
             </a:r>
             <a:endParaRPr lang="en-US" dirty="0"/>
           </a:p>
@@ -3186,7 +3190,7 @@
           <a:p>
             <a:r>
               <a:rPr lang="en-US" dirty="0"/>
-              <a:t>The expected answer is: because of the enormous pressure. If you got it right, well done.</a:t>
+              <a:t>Copy the point on The inner core on the left, then draw the diagram on the right: the centre of the Earth. Give it a title and label it clearly.</a:t>
             </a:r>
             <a:endParaRPr lang="en-US" dirty="0"/>
           </a:p>
@@ -3274,7 +3278,7 @@
           <a:p>
             <a:r>
               <a:rPr lang="en-US" dirty="0"/>
-              <a:t>For those who need more practice, fill in the blanks in your exercise book. The answers are: number 1, crust; number 2, mantle; number 3, liquid.</a:t>
+              <a:t>Now let us check what you have understood. Question 1: Name the layer on which we live. Answer in your exercise book.</a:t>
             </a:r>
             <a:endParaRPr lang="en-US" dirty="0"/>
           </a:p>
@@ -3362,7 +3366,7 @@
           <a:p>
             <a:r>
               <a:rPr lang="en-US" dirty="0"/>
-              <a:t>For your homework: Collect three different stones or building materials (for example a piece of granite, a sandstone block and a piece of marble or tile). Write where you found each one. We shall correct it at the beginning of our next lesson.</a:t>
+              <a:t>The expected answer is: the crust. If you got it right, well done.</a:t>
             </a:r>
             <a:endParaRPr lang="en-US" dirty="0"/>
           </a:p>
@@ -3538,7 +3542,7 @@
           <a:p>
             <a:r>
               <a:rPr lang="en-US" dirty="0"/>
-              <a:t>Our next lesson will be on Lesson 8: Rocks. Thank you for your attention, and see you next time.</a:t>
+              <a:t>Now let us check what you have understood. Question 2: Why is the inner core solid though it is very hot? Answer in your exercise book.</a:t>
             </a:r>
             <a:endParaRPr lang="en-US" dirty="0"/>
           </a:p>
@@ -3626,7 +3630,7 @@
           <a:p>
             <a:r>
               <a:rPr lang="en-US" dirty="0"/>
-              <a:t>Let us play the bilingual game. I say a word in English, and you give me the French word. Then we do the reverse.</a:t>
+              <a:t>The expected answer is: because of the enormous pressure. If you got it right, well done.</a:t>
             </a:r>
             <a:endParaRPr lang="en-US" dirty="0"/>
           </a:p>
@@ -3714,7 +3718,7 @@
           <a:p>
             <a:r>
               <a:rPr lang="en-US" dirty="0"/>
-              <a:t>I record this information in the official logbook of the class after the lesson.</a:t>
+              <a:t>For those who need more practice, fill in the blanks in your exercise book. The answers are: number 1, crust; number 2, mantle; number 3, liquid.</a:t>
             </a:r>
             <a:endParaRPr lang="en-US" dirty="0"/>
           </a:p>
@@ -3802,7 +3806,7 @@
           <a:p>
             <a:r>
               <a:rPr lang="en-US" dirty="0"/>
-              <a:t>I complete the second page of the logbook: the matter taught, the evaluation, the homework and the attendance.</a:t>
+              <a:t>For your homework: Collect three different stones or building materials (for example a piece of granite, a sandstone block and a piece of marble or tile). Write where you found each one. We shall correct it at the beginning of our next lesson.</a:t>
             </a:r>
             <a:endParaRPr lang="en-US" dirty="0"/>
           </a:p>
@@ -3890,7 +3894,7 @@
           <a:p>
             <a:r>
               <a:rPr lang="en-US" dirty="0"/>
-              <a:t>This slide is for me, the teacher: it gives the timing of the lesson and what to do if the projector is not available.</a:t>
+              <a:t>Our next lesson will be on Lesson 8: Rocks. Thank you for your attention, and see you next time.</a:t>
             </a:r>
             <a:endParaRPr lang="en-US" dirty="0"/>
           </a:p>
@@ -3978,7 +3982,7 @@
           <a:p>
             <a:r>
               <a:rPr lang="en-US" dirty="0"/>
-              <a:t>These are the references and picture credits used to prepare this lesson.</a:t>
+              <a:t>Let us play the bilingual game. I say a word in English, and you give me the French word. Then we do the reverse.</a:t>
             </a:r>
             <a:endParaRPr lang="en-US" dirty="0"/>
           </a:p>
@@ -4002,6 +4006,358 @@
             <a:fld id="{F7021451-1387-4CA6-816F-3879F97B5CBC}" type="slidenum">
               <a:rPr lang="en-US"/>
               <a:t>45</a:t>
+            </a:fld>
+            <a:endParaRPr lang="en-US"/>
+          </a:p>
+        </p:txBody>
+      </p:sp>
+    </p:spTree>
+    <p:extLst>
+      <p:ext uri="{BB962C8B-B14F-4D97-AF65-F5344CB8AC3E}">
+        <p14:creationId xmlns:p14="http://schemas.microsoft.com/office/powerpoint/2010/main" val="1024086991"/>
+      </p:ext>
+    </p:extLst>
+  </p:cSld>
+  <p:clrMapOvr>
+    <a:masterClrMapping/>
+  </p:clrMapOvr>
+</p:notes>
+</file>
+
+<file path=ppt/notesSlides/notesSlide46.xml><?xml version="1.0" encoding="utf-8"?>
+<p:notes xmlns:a="http://schemas.openxmlformats.org/drawingml/2006/main" xmlns:r="http://schemas.openxmlformats.org/officeDocument/2006/relationships" xmlns:p="http://schemas.openxmlformats.org/presentationml/2006/main">
+  <p:cSld>
+    <p:spTree>
+      <p:nvGrpSpPr>
+        <p:cNvPr id="1" name=""/>
+        <p:cNvGrpSpPr/>
+        <p:nvPr/>
+      </p:nvGrpSpPr>
+      <p:grpSpPr>
+        <a:xfrm>
+          <a:off x="0" y="0"/>
+          <a:ext cx="0" cy="0"/>
+          <a:chOff x="0" y="0"/>
+          <a:chExt cx="0" cy="0"/>
+        </a:xfrm>
+      </p:grpSpPr>
+      <p:sp>
+        <p:nvSpPr>
+          <p:cNvPr id="2" name="Slide Image Placeholder 1"/>
+          <p:cNvSpPr>
+            <a:spLocks noGrp="1" noRot="1" noChangeAspect="1"/>
+          </p:cNvSpPr>
+          <p:nvPr>
+            <p:ph type="sldImg"/>
+          </p:nvPr>
+        </p:nvSpPr>
+        <p:spPr/>
+      </p:sp>
+      <p:sp>
+        <p:nvSpPr>
+          <p:cNvPr id="3" name="Notes Placeholder 2"/>
+          <p:cNvSpPr>
+            <a:spLocks noGrp="1"/>
+          </p:cNvSpPr>
+          <p:nvPr>
+            <p:ph type="body" idx="1"/>
+          </p:nvPr>
+        </p:nvSpPr>
+        <p:spPr/>
+        <p:txBody>
+          <a:bodyPr/>
+          <a:lstStyle/>
+          <a:p>
+            <a:r>
+              <a:rPr lang="en-US" dirty="0"/>
+              <a:t>I record this information in the official logbook of the class after the lesson.</a:t>
+            </a:r>
+            <a:endParaRPr lang="en-US" dirty="0"/>
+          </a:p>
+        </p:txBody>
+      </p:sp>
+      <p:sp>
+        <p:nvSpPr>
+          <p:cNvPr id="4" name="Slide Number Placeholder 3"/>
+          <p:cNvSpPr>
+            <a:spLocks noGrp="1"/>
+          </p:cNvSpPr>
+          <p:nvPr>
+            <p:ph type="sldNum" sz="quarter" idx="10"/>
+          </p:nvPr>
+        </p:nvSpPr>
+        <p:spPr/>
+        <p:txBody>
+          <a:bodyPr/>
+          <a:lstStyle/>
+          <a:p>
+            <a:fld id="{F7021451-1387-4CA6-816F-3879F97B5CBC}" type="slidenum">
+              <a:rPr lang="en-US"/>
+              <a:t>46</a:t>
+            </a:fld>
+            <a:endParaRPr lang="en-US"/>
+          </a:p>
+        </p:txBody>
+      </p:sp>
+    </p:spTree>
+    <p:extLst>
+      <p:ext uri="{BB962C8B-B14F-4D97-AF65-F5344CB8AC3E}">
+        <p14:creationId xmlns:p14="http://schemas.microsoft.com/office/powerpoint/2010/main" val="1024086991"/>
+      </p:ext>
+    </p:extLst>
+  </p:cSld>
+  <p:clrMapOvr>
+    <a:masterClrMapping/>
+  </p:clrMapOvr>
+</p:notes>
+</file>
+
+<file path=ppt/notesSlides/notesSlide47.xml><?xml version="1.0" encoding="utf-8"?>
+<p:notes xmlns:a="http://schemas.openxmlformats.org/drawingml/2006/main" xmlns:r="http://schemas.openxmlformats.org/officeDocument/2006/relationships" xmlns:p="http://schemas.openxmlformats.org/presentationml/2006/main">
+  <p:cSld>
+    <p:spTree>
+      <p:nvGrpSpPr>
+        <p:cNvPr id="1" name=""/>
+        <p:cNvGrpSpPr/>
+        <p:nvPr/>
+      </p:nvGrpSpPr>
+      <p:grpSpPr>
+        <a:xfrm>
+          <a:off x="0" y="0"/>
+          <a:ext cx="0" cy="0"/>
+          <a:chOff x="0" y="0"/>
+          <a:chExt cx="0" cy="0"/>
+        </a:xfrm>
+      </p:grpSpPr>
+      <p:sp>
+        <p:nvSpPr>
+          <p:cNvPr id="2" name="Slide Image Placeholder 1"/>
+          <p:cNvSpPr>
+            <a:spLocks noGrp="1" noRot="1" noChangeAspect="1"/>
+          </p:cNvSpPr>
+          <p:nvPr>
+            <p:ph type="sldImg"/>
+          </p:nvPr>
+        </p:nvSpPr>
+        <p:spPr/>
+      </p:sp>
+      <p:sp>
+        <p:nvSpPr>
+          <p:cNvPr id="3" name="Notes Placeholder 2"/>
+          <p:cNvSpPr>
+            <a:spLocks noGrp="1"/>
+          </p:cNvSpPr>
+          <p:nvPr>
+            <p:ph type="body" idx="1"/>
+          </p:nvPr>
+        </p:nvSpPr>
+        <p:spPr/>
+        <p:txBody>
+          <a:bodyPr/>
+          <a:lstStyle/>
+          <a:p>
+            <a:r>
+              <a:rPr lang="en-US" dirty="0"/>
+              <a:t>I complete the second page of the logbook: the matter taught, the evaluation, the homework and the attendance.</a:t>
+            </a:r>
+            <a:endParaRPr lang="en-US" dirty="0"/>
+          </a:p>
+        </p:txBody>
+      </p:sp>
+      <p:sp>
+        <p:nvSpPr>
+          <p:cNvPr id="4" name="Slide Number Placeholder 3"/>
+          <p:cNvSpPr>
+            <a:spLocks noGrp="1"/>
+          </p:cNvSpPr>
+          <p:nvPr>
+            <p:ph type="sldNum" sz="quarter" idx="10"/>
+          </p:nvPr>
+        </p:nvSpPr>
+        <p:spPr/>
+        <p:txBody>
+          <a:bodyPr/>
+          <a:lstStyle/>
+          <a:p>
+            <a:fld id="{F7021451-1387-4CA6-816F-3879F97B5CBC}" type="slidenum">
+              <a:rPr lang="en-US"/>
+              <a:t>47</a:t>
+            </a:fld>
+            <a:endParaRPr lang="en-US"/>
+          </a:p>
+        </p:txBody>
+      </p:sp>
+    </p:spTree>
+    <p:extLst>
+      <p:ext uri="{BB962C8B-B14F-4D97-AF65-F5344CB8AC3E}">
+        <p14:creationId xmlns:p14="http://schemas.microsoft.com/office/powerpoint/2010/main" val="1024086991"/>
+      </p:ext>
+    </p:extLst>
+  </p:cSld>
+  <p:clrMapOvr>
+    <a:masterClrMapping/>
+  </p:clrMapOvr>
+</p:notes>
+</file>
+
+<file path=ppt/notesSlides/notesSlide48.xml><?xml version="1.0" encoding="utf-8"?>
+<p:notes xmlns:a="http://schemas.openxmlformats.org/drawingml/2006/main" xmlns:r="http://schemas.openxmlformats.org/officeDocument/2006/relationships" xmlns:p="http://schemas.openxmlformats.org/presentationml/2006/main">
+  <p:cSld>
+    <p:spTree>
+      <p:nvGrpSpPr>
+        <p:cNvPr id="1" name=""/>
+        <p:cNvGrpSpPr/>
+        <p:nvPr/>
+      </p:nvGrpSpPr>
+      <p:grpSpPr>
+        <a:xfrm>
+          <a:off x="0" y="0"/>
+          <a:ext cx="0" cy="0"/>
+          <a:chOff x="0" y="0"/>
+          <a:chExt cx="0" cy="0"/>
+        </a:xfrm>
+      </p:grpSpPr>
+      <p:sp>
+        <p:nvSpPr>
+          <p:cNvPr id="2" name="Slide Image Placeholder 1"/>
+          <p:cNvSpPr>
+            <a:spLocks noGrp="1" noRot="1" noChangeAspect="1"/>
+          </p:cNvSpPr>
+          <p:nvPr>
+            <p:ph type="sldImg"/>
+          </p:nvPr>
+        </p:nvSpPr>
+        <p:spPr/>
+      </p:sp>
+      <p:sp>
+        <p:nvSpPr>
+          <p:cNvPr id="3" name="Notes Placeholder 2"/>
+          <p:cNvSpPr>
+            <a:spLocks noGrp="1"/>
+          </p:cNvSpPr>
+          <p:nvPr>
+            <p:ph type="body" idx="1"/>
+          </p:nvPr>
+        </p:nvSpPr>
+        <p:spPr/>
+        <p:txBody>
+          <a:bodyPr/>
+          <a:lstStyle/>
+          <a:p>
+            <a:r>
+              <a:rPr lang="en-US" dirty="0"/>
+              <a:t>This slide is for me, the teacher: it gives the timing of the lesson and what to do if the projector is not available.</a:t>
+            </a:r>
+            <a:endParaRPr lang="en-US" dirty="0"/>
+          </a:p>
+        </p:txBody>
+      </p:sp>
+      <p:sp>
+        <p:nvSpPr>
+          <p:cNvPr id="4" name="Slide Number Placeholder 3"/>
+          <p:cNvSpPr>
+            <a:spLocks noGrp="1"/>
+          </p:cNvSpPr>
+          <p:nvPr>
+            <p:ph type="sldNum" sz="quarter" idx="10"/>
+          </p:nvPr>
+        </p:nvSpPr>
+        <p:spPr/>
+        <p:txBody>
+          <a:bodyPr/>
+          <a:lstStyle/>
+          <a:p>
+            <a:fld id="{F7021451-1387-4CA6-816F-3879F97B5CBC}" type="slidenum">
+              <a:rPr lang="en-US"/>
+              <a:t>48</a:t>
+            </a:fld>
+            <a:endParaRPr lang="en-US"/>
+          </a:p>
+        </p:txBody>
+      </p:sp>
+    </p:spTree>
+    <p:extLst>
+      <p:ext uri="{BB962C8B-B14F-4D97-AF65-F5344CB8AC3E}">
+        <p14:creationId xmlns:p14="http://schemas.microsoft.com/office/powerpoint/2010/main" val="1024086991"/>
+      </p:ext>
+    </p:extLst>
+  </p:cSld>
+  <p:clrMapOvr>
+    <a:masterClrMapping/>
+  </p:clrMapOvr>
+</p:notes>
+</file>
+
+<file path=ppt/notesSlides/notesSlide49.xml><?xml version="1.0" encoding="utf-8"?>
+<p:notes xmlns:a="http://schemas.openxmlformats.org/drawingml/2006/main" xmlns:r="http://schemas.openxmlformats.org/officeDocument/2006/relationships" xmlns:p="http://schemas.openxmlformats.org/presentationml/2006/main">
+  <p:cSld>
+    <p:spTree>
+      <p:nvGrpSpPr>
+        <p:cNvPr id="1" name=""/>
+        <p:cNvGrpSpPr/>
+        <p:nvPr/>
+      </p:nvGrpSpPr>
+      <p:grpSpPr>
+        <a:xfrm>
+          <a:off x="0" y="0"/>
+          <a:ext cx="0" cy="0"/>
+          <a:chOff x="0" y="0"/>
+          <a:chExt cx="0" cy="0"/>
+        </a:xfrm>
+      </p:grpSpPr>
+      <p:sp>
+        <p:nvSpPr>
+          <p:cNvPr id="2" name="Slide Image Placeholder 1"/>
+          <p:cNvSpPr>
+            <a:spLocks noGrp="1" noRot="1" noChangeAspect="1"/>
+          </p:cNvSpPr>
+          <p:nvPr>
+            <p:ph type="sldImg"/>
+          </p:nvPr>
+        </p:nvSpPr>
+        <p:spPr/>
+      </p:sp>
+      <p:sp>
+        <p:nvSpPr>
+          <p:cNvPr id="3" name="Notes Placeholder 2"/>
+          <p:cNvSpPr>
+            <a:spLocks noGrp="1"/>
+          </p:cNvSpPr>
+          <p:nvPr>
+            <p:ph type="body" idx="1"/>
+          </p:nvPr>
+        </p:nvSpPr>
+        <p:spPr/>
+        <p:txBody>
+          <a:bodyPr/>
+          <a:lstStyle/>
+          <a:p>
+            <a:r>
+              <a:rPr lang="en-US" dirty="0"/>
+              <a:t>These are the references and picture credits used to prepare this lesson.</a:t>
+            </a:r>
+            <a:endParaRPr lang="en-US" dirty="0"/>
+          </a:p>
+        </p:txBody>
+      </p:sp>
+      <p:sp>
+        <p:nvSpPr>
+          <p:cNvPr id="4" name="Slide Number Placeholder 3"/>
+          <p:cNvSpPr>
+            <a:spLocks noGrp="1"/>
+          </p:cNvSpPr>
+          <p:nvPr>
+            <p:ph type="sldNum" sz="quarter" idx="10"/>
+          </p:nvPr>
+        </p:nvSpPr>
+        <p:spPr/>
+        <p:txBody>
+          <a:bodyPr/>
+          <a:lstStyle/>
+          <a:p>
+            <a:fld id="{F7021451-1387-4CA6-816F-3879F97B5CBC}" type="slidenum">
+              <a:rPr lang="en-US"/>
+              <a:t>49</a:t>
             </a:fld>
             <a:endParaRPr lang="en-US"/>
           </a:p>
@@ -5798,7 +6154,7 @@
         <p:spPr>
           <a:xfrm>
             <a:off x="0" y="658368"/>
-            <a:ext cx="5120640" cy="5833872"/>
+            <a:ext cx="3840480" cy="5833872"/>
           </a:xfrm>
           <a:prstGeom prst="rect">
             <a:avLst/>
@@ -5813,8 +6169,8 @@
         </p:nvSpPr>
         <p:spPr>
           <a:xfrm>
-            <a:off x="5349240" y="1005840"/>
-            <a:ext cx="6522415" cy="731520"/>
+            <a:off x="4069080" y="1005840"/>
+            <a:ext cx="7802575" cy="731520"/>
           </a:xfrm>
           <a:prstGeom prst="rect">
             <a:avLst/>
@@ -5854,8 +6210,8 @@
         </p:nvSpPr>
         <p:spPr>
           <a:xfrm>
-            <a:off x="5349240" y="1783080"/>
-            <a:ext cx="6522415" cy="4663440"/>
+            <a:off x="4069080" y="1783080"/>
+            <a:ext cx="7802575" cy="4663440"/>
           </a:xfrm>
           <a:prstGeom prst="rect">
             <a:avLst/>
@@ -5882,7 +6238,7 @@
                 <a:ea typeface="Times New Roman" pitchFamily="34" charset="-122"/>
                 <a:cs typeface="Times New Roman" pitchFamily="34" charset="-120"/>
               </a:rPr>
-              <a:t>Workers dig a deep well in Garoua. First they dig through red soil. Then they reach very hard rock. Amadou wonders what they would find if they could dig to the centre of the Earth.</a:t>
+              <a:t>Workers dig a deep well in Garoua. First they dig through red soil, then they reach very hard rock and must stop. Amadou asks: "What would we find if we could dig down to the centre of the Earth?"</a:t>
             </a:r>
             <a:endParaRPr lang="en-US" sz="4000" dirty="0"/>
           </a:p>
@@ -6320,7 +6676,7 @@
                 <a:ea typeface="Times New Roman" pitchFamily="34" charset="-122"/>
                 <a:cs typeface="Times New Roman" pitchFamily="34" charset="-120"/>
               </a:rPr>
-              <a:t>Amadou does not know what is inside the Earth.</a:t>
+              <a:t>Amadou does not know what is inside the Earth, under the rock.</a:t>
             </a:r>
             <a:endParaRPr lang="en-US" sz="4000" dirty="0"/>
           </a:p>
@@ -7196,7 +7552,7 @@
                 <a:ea typeface="Times New Roman" pitchFamily="34" charset="-122"/>
                 <a:cs typeface="Times New Roman" pitchFamily="34" charset="-120"/>
               </a:rPr>
-              <a:t>No. It is too deep and too hot.</a:t>
+              <a:t>No: it is about 6,370 km deep and far too hot.</a:t>
             </a:r>
             <a:endParaRPr lang="en-US" sz="4000" dirty="0"/>
           </a:p>
@@ -7746,7 +8102,7 @@
                 <a:ea typeface="Calibri" pitchFamily="34" charset="-122"/>
                 <a:cs typeface="Calibri" pitchFamily="34" charset="-120"/>
               </a:rPr>
-              <a:t>2. THE CRUST</a:t>
+              <a:t>1. ILLUSTRATIONS</a:t>
             </a:r>
             <a:endParaRPr lang="en-US" sz="1400" dirty="0"/>
           </a:p>
@@ -7793,7 +8149,7 @@
       </p:sp>
       <p:pic>
         <p:nvPicPr>
-          <p:cNvPr id="4" name="Image 0" descr="/home/claude/f4/img/v2/f2t_laterite.jpg">    </p:cNvPr>
+          <p:cNvPr id="4" name="Image 0" descr="/home/claude/f4/img/v2/earth_layers_big.png">    </p:cNvPr>
           <p:cNvPicPr>
             <a:picLocks noChangeAspect="1"/>
           </p:cNvPicPr>
@@ -7807,8 +8163,8 @@
         </p:blipFill>
         <p:spPr>
           <a:xfrm>
-            <a:off x="2248777" y="1783080"/>
-            <a:ext cx="7694141" cy="4270248"/>
+            <a:off x="629930" y="1783080"/>
+            <a:ext cx="10931835" cy="4270248"/>
           </a:xfrm>
           <a:prstGeom prst="rect">
             <a:avLst/>
@@ -7848,7 +8204,7 @@
                 <a:ea typeface="Times New Roman" pitchFamily="34" charset="-122"/>
                 <a:cs typeface="Times New Roman" pitchFamily="34" charset="-120"/>
               </a:rPr>
-              <a:t>People dig a big pit in the ground.</a:t>
+              <a:t>The layers of the Earth.</a:t>
             </a:r>
             <a:endParaRPr lang="en-US" sz="1800" dirty="0"/>
           </a:p>
@@ -8555,7 +8911,7 @@
                 <a:ea typeface="Calibri" pitchFamily="34" charset="-122"/>
                 <a:cs typeface="Calibri" pitchFamily="34" charset="-120"/>
               </a:rPr>
-              <a:t>2. THE CRUST</a:t>
+              <a:t>1. ILLUSTRATIONS</a:t>
             </a:r>
             <a:endParaRPr lang="en-US" sz="1400" dirty="0"/>
           </a:p>
@@ -8620,7 +8976,7 @@
                 <a:ea typeface="Times New Roman" pitchFamily="34" charset="-122"/>
                 <a:cs typeface="Times New Roman" pitchFamily="34" charset="-120"/>
               </a:rPr>
-              <a:t>Activity 1: Question</a:t>
+              <a:t>Activity 1: Question 1</a:t>
             </a:r>
             <a:endParaRPr lang="en-US" sz="3600" dirty="0"/>
           </a:p>
@@ -8662,7 +9018,7 @@
                 <a:ea typeface="Times New Roman" pitchFamily="34" charset="-122"/>
                 <a:cs typeface="Times New Roman" pitchFamily="34" charset="-120"/>
               </a:rPr>
-              <a:t>When we dig, which layer of the Earth do we reach?</a:t>
+              <a:t>How many main layers does the Earth have?</a:t>
             </a:r>
             <a:endParaRPr lang="en-US" sz="4000" dirty="0"/>
           </a:p>
@@ -8774,7 +9130,7 @@
                 <a:ea typeface="Calibri" pitchFamily="34" charset="-122"/>
                 <a:cs typeface="Calibri" pitchFamily="34" charset="-120"/>
               </a:rPr>
-              <a:t>2. THE CRUST</a:t>
+              <a:t>1. ILLUSTRATIONS</a:t>
             </a:r>
             <a:endParaRPr lang="en-US" sz="1400" dirty="0"/>
           </a:p>
@@ -8839,7 +9195,7 @@
                 <a:ea typeface="Times New Roman" pitchFamily="34" charset="-122"/>
                 <a:cs typeface="Times New Roman" pitchFamily="34" charset="-120"/>
               </a:rPr>
-              <a:t>Activity 1: Answer</a:t>
+              <a:t>Activity 1: Answer 1</a:t>
             </a:r>
             <a:endParaRPr lang="en-US" sz="3600" dirty="0"/>
           </a:p>
@@ -8881,7 +9237,7 @@
                 <a:ea typeface="Times New Roman" pitchFamily="34" charset="-122"/>
                 <a:cs typeface="Times New Roman" pitchFamily="34" charset="-120"/>
               </a:rPr>
-              <a:t>Only the crust, the thin outer layer.</a:t>
+              <a:t>Four: crust, mantle, outer core and inner core.</a:t>
             </a:r>
             <a:endParaRPr lang="en-US" sz="4000" dirty="0"/>
           </a:p>
@@ -8993,54 +9349,15 @@
                 <a:ea typeface="Calibri" pitchFamily="34" charset="-122"/>
                 <a:cs typeface="Calibri" pitchFamily="34" charset="-120"/>
               </a:rPr>
-              <a:t>1. ILLUSTRATION OF THE LAYERS</a:t>
+              <a:t>1. ILLUSTRATIONS</a:t>
             </a:r>
             <a:endParaRPr lang="en-US" sz="1400" dirty="0"/>
-          </a:p>
-        </p:txBody>
-      </p:sp>
-      <p:sp>
-        <p:nvSpPr>
-          <p:cNvPr id="3" name="Text 1"/>
-          <p:cNvSpPr/>
-          <p:nvPr/>
-        </p:nvSpPr>
-        <p:spPr>
-          <a:xfrm>
-            <a:off x="457200" y="1005840"/>
-            <a:ext cx="11277295" cy="731520"/>
-          </a:xfrm>
-          <a:prstGeom prst="rect">
-            <a:avLst/>
-          </a:prstGeom>
-          <a:noFill/>
-          <a:ln/>
-        </p:spPr>
-        <p:txBody>
-          <a:bodyPr wrap="square" lIns="0" tIns="0" rIns="0" bIns="0" rtlCol="0" anchor="ctr"/>
-          <a:lstStyle/>
-          <a:p>
-            <a:pPr algn="ctr" indent="0" marL="0">
-              <a:buNone/>
-            </a:pPr>
-            <a:r>
-              <a:rPr lang="en-US" sz="3600" b="1" dirty="0">
-                <a:solidFill>
-                  <a:srgbClr val="990011"/>
-                </a:solidFill>
-                <a:latin typeface="Times New Roman" pitchFamily="34" charset="0"/>
-                <a:ea typeface="Times New Roman" pitchFamily="34" charset="-122"/>
-                <a:cs typeface="Times New Roman" pitchFamily="34" charset="-120"/>
-              </a:rPr>
-              <a:t>Activity 2</a:t>
-            </a:r>
-            <a:endParaRPr lang="en-US" sz="3600" dirty="0"/>
           </a:p>
         </p:txBody>
       </p:sp>
       <p:pic>
         <p:nvPicPr>
-          <p:cNvPr id="4" name="Image 0" descr="/home/claude/f4/img/v2/earth_layers_big.png">    </p:cNvPr>
+          <p:cNvPr id="3" name="Image 0" descr="/home/claude/f4/img/minesec_sheet.png">    </p:cNvPr>
           <p:cNvPicPr>
             <a:picLocks noChangeAspect="1"/>
           </p:cNvPicPr>
@@ -9054,8 +9371,8 @@
         </p:blipFill>
         <p:spPr>
           <a:xfrm>
-            <a:off x="629930" y="1783080"/>
-            <a:ext cx="10931835" cy="4270248"/>
+            <a:off x="0" y="658368"/>
+            <a:ext cx="5120640" cy="5833872"/>
           </a:xfrm>
           <a:prstGeom prst="rect">
             <a:avLst/>
@@ -9064,14 +9381,14 @@
       </p:pic>
       <p:sp>
         <p:nvSpPr>
-          <p:cNvPr id="5" name="Text 2"/>
+          <p:cNvPr id="4" name="Text 1"/>
           <p:cNvSpPr/>
           <p:nvPr/>
         </p:nvSpPr>
         <p:spPr>
           <a:xfrm>
-            <a:off x="457200" y="6089904"/>
-            <a:ext cx="11277295" cy="347472"/>
+            <a:off x="5349240" y="1005840"/>
+            <a:ext cx="6522415" cy="731520"/>
           </a:xfrm>
           <a:prstGeom prst="rect">
             <a:avLst/>
@@ -9080,24 +9397,68 @@
           <a:ln/>
         </p:spPr>
         <p:txBody>
-          <a:bodyPr wrap="square" lIns="0" tIns="0" rIns="0" bIns="0" rtlCol="0" anchor="ctr"/>
+          <a:bodyPr wrap="square" lIns="0" tIns="0" rIns="0" bIns="0" rtlCol="0" anchor="ctr">
+            <a:normAutofit/>
+          </a:bodyPr>
           <a:lstStyle/>
           <a:p>
             <a:pPr algn="ctr" indent="0" marL="0">
               <a:buNone/>
             </a:pPr>
             <a:r>
-              <a:rPr lang="en-US" sz="1800" i="1" dirty="0">
-                <a:solidFill>
-                  <a:srgbClr val="555555"/>
+              <a:rPr lang="en-US" sz="3600" b="1" dirty="0">
+                <a:solidFill>
+                  <a:srgbClr val="990011"/>
                 </a:solidFill>
                 <a:latin typeface="Times New Roman" pitchFamily="34" charset="0"/>
                 <a:ea typeface="Times New Roman" pitchFamily="34" charset="-122"/>
                 <a:cs typeface="Times New Roman" pitchFamily="34" charset="-120"/>
               </a:rPr>
-              <a:t>The layers of the Earth.</a:t>
-            </a:r>
-            <a:endParaRPr lang="en-US" sz="1800" dirty="0"/>
+              <a:t>Activity 1: Question 2</a:t>
+            </a:r>
+            <a:endParaRPr lang="en-US" sz="3600" dirty="0"/>
+          </a:p>
+        </p:txBody>
+      </p:sp>
+      <p:sp>
+        <p:nvSpPr>
+          <p:cNvPr id="5" name="Text 2"/>
+          <p:cNvSpPr/>
+          <p:nvPr/>
+        </p:nvSpPr>
+        <p:spPr>
+          <a:xfrm>
+            <a:off x="5349240" y="1783080"/>
+            <a:ext cx="6522415" cy="4663440"/>
+          </a:xfrm>
+          <a:prstGeom prst="rect">
+            <a:avLst/>
+          </a:prstGeom>
+          <a:noFill/>
+          <a:ln/>
+        </p:spPr>
+        <p:txBody>
+          <a:bodyPr wrap="square" lIns="0" tIns="0" rIns="0" bIns="0" rtlCol="0" anchor="t"/>
+          <a:lstStyle/>
+          <a:p>
+            <a:pPr algn="l" indent="0" marL="0">
+              <a:spcAft>
+                <a:spcPts val="800"/>
+              </a:spcAft>
+              <a:buNone/>
+            </a:pPr>
+            <a:r>
+              <a:rPr lang="en-US" sz="4000" dirty="0">
+                <a:solidFill>
+                  <a:srgbClr val="111111"/>
+                </a:solidFill>
+                <a:latin typeface="Times New Roman" pitchFamily="34" charset="0"/>
+                <a:ea typeface="Times New Roman" pitchFamily="34" charset="-122"/>
+                <a:cs typeface="Times New Roman" pitchFamily="34" charset="-120"/>
+              </a:rPr>
+              <a:t>Which layer is in the centre?</a:t>
+            </a:r>
+            <a:endParaRPr lang="en-US" sz="4000" dirty="0"/>
           </a:p>
         </p:txBody>
       </p:sp>
@@ -9207,7 +9568,7 @@
                 <a:ea typeface="Calibri" pitchFamily="34" charset="-122"/>
                 <a:cs typeface="Calibri" pitchFamily="34" charset="-120"/>
               </a:rPr>
-              <a:t>1. ILLUSTRATION OF THE LAYERS</a:t>
+              <a:t>1. ILLUSTRATIONS</a:t>
             </a:r>
             <a:endParaRPr lang="en-US" sz="1400" dirty="0"/>
           </a:p>
@@ -9272,7 +9633,7 @@
                 <a:ea typeface="Times New Roman" pitchFamily="34" charset="-122"/>
                 <a:cs typeface="Times New Roman" pitchFamily="34" charset="-120"/>
               </a:rPr>
-              <a:t>Activity 2: Question</a:t>
+              <a:t>Activity 1: Answer 2</a:t>
             </a:r>
             <a:endParaRPr lang="en-US" sz="3600" dirty="0"/>
           </a:p>
@@ -9314,7 +9675,7 @@
                 <a:ea typeface="Times New Roman" pitchFamily="34" charset="-122"/>
                 <a:cs typeface="Times New Roman" pitchFamily="34" charset="-120"/>
               </a:rPr>
-              <a:t>Name the four layers from the outside to the centre.</a:t>
+              <a:t>The inner core.</a:t>
             </a:r>
             <a:endParaRPr lang="en-US" sz="4000" dirty="0"/>
           </a:p>
@@ -9426,15 +9787,54 @@
                 <a:ea typeface="Calibri" pitchFamily="34" charset="-122"/>
                 <a:cs typeface="Calibri" pitchFamily="34" charset="-120"/>
               </a:rPr>
-              <a:t>1. ILLUSTRATION OF THE LAYERS</a:t>
+              <a:t>2. THE MAIN LAYERS</a:t>
             </a:r>
             <a:endParaRPr lang="en-US" sz="1400" dirty="0"/>
+          </a:p>
+        </p:txBody>
+      </p:sp>
+      <p:sp>
+        <p:nvSpPr>
+          <p:cNvPr id="3" name="Text 1"/>
+          <p:cNvSpPr/>
+          <p:nvPr/>
+        </p:nvSpPr>
+        <p:spPr>
+          <a:xfrm>
+            <a:off x="457200" y="1005840"/>
+            <a:ext cx="11277295" cy="731520"/>
+          </a:xfrm>
+          <a:prstGeom prst="rect">
+            <a:avLst/>
+          </a:prstGeom>
+          <a:noFill/>
+          <a:ln/>
+        </p:spPr>
+        <p:txBody>
+          <a:bodyPr wrap="square" lIns="0" tIns="0" rIns="0" bIns="0" rtlCol="0" anchor="ctr"/>
+          <a:lstStyle/>
+          <a:p>
+            <a:pPr algn="ctr" indent="0" marL="0">
+              <a:buNone/>
+            </a:pPr>
+            <a:r>
+              <a:rPr lang="en-US" sz="3600" b="1" dirty="0">
+                <a:solidFill>
+                  <a:srgbClr val="990011"/>
+                </a:solidFill>
+                <a:latin typeface="Times New Roman" pitchFamily="34" charset="0"/>
+                <a:ea typeface="Times New Roman" pitchFamily="34" charset="-122"/>
+                <a:cs typeface="Times New Roman" pitchFamily="34" charset="-120"/>
+              </a:rPr>
+              <a:t>Activity 2</a:t>
+            </a:r>
+            <a:endParaRPr lang="en-US" sz="3600" dirty="0"/>
           </a:p>
         </p:txBody>
       </p:sp>
       <p:pic>
         <p:nvPicPr>
-          <p:cNvPr id="3" name="Image 0" descr="/home/claude/f4/img/minesec_sheet.png">    </p:cNvPr>
+          <p:cNvPr id="4" name="Image 0" descr="/home/claude/f4/img/v2/f2t_laterite.jpg">    </p:cNvPr>
           <p:cNvPicPr>
             <a:picLocks noChangeAspect="1"/>
           </p:cNvPicPr>
@@ -9448,8 +9848,8 @@
         </p:blipFill>
         <p:spPr>
           <a:xfrm>
-            <a:off x="0" y="658368"/>
-            <a:ext cx="5120640" cy="5833872"/>
+            <a:off x="2248777" y="1783080"/>
+            <a:ext cx="7694141" cy="4270248"/>
           </a:xfrm>
           <a:prstGeom prst="rect">
             <a:avLst/>
@@ -9458,14 +9858,14 @@
       </p:pic>
       <p:sp>
         <p:nvSpPr>
-          <p:cNvPr id="4" name="Text 1"/>
+          <p:cNvPr id="5" name="Text 2"/>
           <p:cNvSpPr/>
           <p:nvPr/>
         </p:nvSpPr>
         <p:spPr>
           <a:xfrm>
-            <a:off x="5349240" y="1005840"/>
-            <a:ext cx="6522415" cy="731520"/>
+            <a:off x="457200" y="6089904"/>
+            <a:ext cx="11277295" cy="347472"/>
           </a:xfrm>
           <a:prstGeom prst="rect">
             <a:avLst/>
@@ -9474,68 +9874,24 @@
           <a:ln/>
         </p:spPr>
         <p:txBody>
-          <a:bodyPr wrap="square" lIns="0" tIns="0" rIns="0" bIns="0" rtlCol="0" anchor="ctr">
-            <a:normAutofit/>
-          </a:bodyPr>
+          <a:bodyPr wrap="square" lIns="0" tIns="0" rIns="0" bIns="0" rtlCol="0" anchor="ctr"/>
           <a:lstStyle/>
           <a:p>
             <a:pPr algn="ctr" indent="0" marL="0">
               <a:buNone/>
             </a:pPr>
             <a:r>
-              <a:rPr lang="en-US" sz="3600" b="1" dirty="0">
-                <a:solidFill>
-                  <a:srgbClr val="990011"/>
+              <a:rPr lang="en-US" sz="1800" i="1" dirty="0">
+                <a:solidFill>
+                  <a:srgbClr val="555555"/>
                 </a:solidFill>
                 <a:latin typeface="Times New Roman" pitchFamily="34" charset="0"/>
                 <a:ea typeface="Times New Roman" pitchFamily="34" charset="-122"/>
                 <a:cs typeface="Times New Roman" pitchFamily="34" charset="-120"/>
               </a:rPr>
-              <a:t>Activity 2: Answer</a:t>
-            </a:r>
-            <a:endParaRPr lang="en-US" sz="3600" dirty="0"/>
-          </a:p>
-        </p:txBody>
-      </p:sp>
-      <p:sp>
-        <p:nvSpPr>
-          <p:cNvPr id="5" name="Text 2"/>
-          <p:cNvSpPr/>
-          <p:nvPr/>
-        </p:nvSpPr>
-        <p:spPr>
-          <a:xfrm>
-            <a:off x="5349240" y="1783080"/>
-            <a:ext cx="6522415" cy="4663440"/>
-          </a:xfrm>
-          <a:prstGeom prst="rect">
-            <a:avLst/>
-          </a:prstGeom>
-          <a:noFill/>
-          <a:ln/>
-        </p:spPr>
-        <p:txBody>
-          <a:bodyPr wrap="square" lIns="0" tIns="0" rIns="0" bIns="0" rtlCol="0" anchor="t"/>
-          <a:lstStyle/>
-          <a:p>
-            <a:pPr algn="l" indent="0" marL="0">
-              <a:spcAft>
-                <a:spcPts val="800"/>
-              </a:spcAft>
-              <a:buNone/>
-            </a:pPr>
-            <a:r>
-              <a:rPr lang="en-US" sz="4000" dirty="0">
-                <a:solidFill>
-                  <a:srgbClr val="111111"/>
-                </a:solidFill>
-                <a:latin typeface="Times New Roman" pitchFamily="34" charset="0"/>
-                <a:ea typeface="Times New Roman" pitchFamily="34" charset="-122"/>
-                <a:cs typeface="Times New Roman" pitchFamily="34" charset="-120"/>
-              </a:rPr>
-              <a:t>Crust, mantle, outer core and inner core.</a:t>
-            </a:r>
-            <a:endParaRPr lang="en-US" sz="4000" dirty="0"/>
+              <a:t>People dig a big pit in the ground.</a:t>
+            </a:r>
+            <a:endParaRPr lang="en-US" sz="1800" dirty="0"/>
           </a:p>
         </p:txBody>
       </p:sp>
@@ -9651,48 +10007,9 @@
           </a:p>
         </p:txBody>
       </p:sp>
-      <p:sp>
-        <p:nvSpPr>
-          <p:cNvPr id="3" name="Text 1"/>
-          <p:cNvSpPr/>
-          <p:nvPr/>
-        </p:nvSpPr>
-        <p:spPr>
-          <a:xfrm>
-            <a:off x="457200" y="1005840"/>
-            <a:ext cx="11277295" cy="731520"/>
-          </a:xfrm>
-          <a:prstGeom prst="rect">
-            <a:avLst/>
-          </a:prstGeom>
-          <a:noFill/>
-          <a:ln/>
-        </p:spPr>
-        <p:txBody>
-          <a:bodyPr wrap="square" lIns="0" tIns="0" rIns="0" bIns="0" rtlCol="0" anchor="ctr"/>
-          <a:lstStyle/>
-          <a:p>
-            <a:pPr algn="ctr" indent="0" marL="0">
-              <a:buNone/>
-            </a:pPr>
-            <a:r>
-              <a:rPr lang="en-US" sz="3600" b="1" dirty="0">
-                <a:solidFill>
-                  <a:srgbClr val="990011"/>
-                </a:solidFill>
-                <a:latin typeface="Times New Roman" pitchFamily="34" charset="0"/>
-                <a:ea typeface="Times New Roman" pitchFamily="34" charset="-122"/>
-                <a:cs typeface="Times New Roman" pitchFamily="34" charset="-120"/>
-              </a:rPr>
-              <a:t>Activity 3</a:t>
-            </a:r>
-            <a:endParaRPr lang="en-US" sz="3600" dirty="0"/>
-          </a:p>
-        </p:txBody>
-      </p:sp>
       <p:pic>
         <p:nvPicPr>
-          <p:cNvPr id="4" name="Image 0" descr="/home/claude/f4/img/v2/earth_depth.gif">    </p:cNvPr>
+          <p:cNvPr id="3" name="Image 0" descr="/home/claude/f4/img/minesec_sheet.png">    </p:cNvPr>
           <p:cNvPicPr>
             <a:picLocks noChangeAspect="1"/>
           </p:cNvPicPr>
@@ -9706,8 +10023,8 @@
         </p:blipFill>
         <p:spPr>
           <a:xfrm>
-            <a:off x="629930" y="1783080"/>
-            <a:ext cx="10931835" cy="4270248"/>
+            <a:off x="0" y="658368"/>
+            <a:ext cx="5120640" cy="5833872"/>
           </a:xfrm>
           <a:prstGeom prst="rect">
             <a:avLst/>
@@ -9716,14 +10033,14 @@
       </p:pic>
       <p:sp>
         <p:nvSpPr>
-          <p:cNvPr id="5" name="Text 2"/>
+          <p:cNvPr id="4" name="Text 1"/>
           <p:cNvSpPr/>
           <p:nvPr/>
         </p:nvSpPr>
         <p:spPr>
           <a:xfrm>
-            <a:off x="457200" y="6089904"/>
-            <a:ext cx="11277295" cy="347472"/>
+            <a:off x="5349240" y="1005840"/>
+            <a:ext cx="6522415" cy="731520"/>
           </a:xfrm>
           <a:prstGeom prst="rect">
             <a:avLst/>
@@ -9732,24 +10049,68 @@
           <a:ln/>
         </p:spPr>
         <p:txBody>
-          <a:bodyPr wrap="square" lIns="0" tIns="0" rIns="0" bIns="0" rtlCol="0" anchor="ctr"/>
+          <a:bodyPr wrap="square" lIns="0" tIns="0" rIns="0" bIns="0" rtlCol="0" anchor="ctr">
+            <a:normAutofit/>
+          </a:bodyPr>
           <a:lstStyle/>
           <a:p>
             <a:pPr algn="ctr" indent="0" marL="0">
               <a:buNone/>
             </a:pPr>
             <a:r>
-              <a:rPr lang="en-US" sz="1800" i="1" dirty="0">
-                <a:solidFill>
-                  <a:srgbClr val="555555"/>
+              <a:rPr lang="en-US" sz="3600" b="1" dirty="0">
+                <a:solidFill>
+                  <a:srgbClr val="990011"/>
                 </a:solidFill>
                 <a:latin typeface="Times New Roman" pitchFamily="34" charset="0"/>
                 <a:ea typeface="Times New Roman" pitchFamily="34" charset="-122"/>
                 <a:cs typeface="Times New Roman" pitchFamily="34" charset="-120"/>
               </a:rPr>
-              <a:t>Animation: a journey to the centre of the Earth.</a:t>
-            </a:r>
-            <a:endParaRPr lang="en-US" sz="1800" dirty="0"/>
+              <a:t>Activity 2: Question</a:t>
+            </a:r>
+            <a:endParaRPr lang="en-US" sz="3600" dirty="0"/>
+          </a:p>
+        </p:txBody>
+      </p:sp>
+      <p:sp>
+        <p:nvSpPr>
+          <p:cNvPr id="5" name="Text 2"/>
+          <p:cNvSpPr/>
+          <p:nvPr/>
+        </p:nvSpPr>
+        <p:spPr>
+          <a:xfrm>
+            <a:off x="5349240" y="1783080"/>
+            <a:ext cx="6522415" cy="4663440"/>
+          </a:xfrm>
+          <a:prstGeom prst="rect">
+            <a:avLst/>
+          </a:prstGeom>
+          <a:noFill/>
+          <a:ln/>
+        </p:spPr>
+        <p:txBody>
+          <a:bodyPr wrap="square" lIns="0" tIns="0" rIns="0" bIns="0" rtlCol="0" anchor="t"/>
+          <a:lstStyle/>
+          <a:p>
+            <a:pPr algn="l" indent="0" marL="0">
+              <a:spcAft>
+                <a:spcPts val="800"/>
+              </a:spcAft>
+              <a:buNone/>
+            </a:pPr>
+            <a:r>
+              <a:rPr lang="en-US" sz="4000" dirty="0">
+                <a:solidFill>
+                  <a:srgbClr val="111111"/>
+                </a:solidFill>
+                <a:latin typeface="Times New Roman" pitchFamily="34" charset="0"/>
+                <a:ea typeface="Times New Roman" pitchFamily="34" charset="-122"/>
+                <a:cs typeface="Times New Roman" pitchFamily="34" charset="-120"/>
+              </a:rPr>
+              <a:t>When we dig a well, which layer of the Earth do we reach?</a:t>
+            </a:r>
+            <a:endParaRPr lang="en-US" sz="4000" dirty="0"/>
           </a:p>
         </p:txBody>
       </p:sp>
@@ -9924,7 +10285,7 @@
                 <a:ea typeface="Times New Roman" pitchFamily="34" charset="-122"/>
                 <a:cs typeface="Times New Roman" pitchFamily="34" charset="-120"/>
               </a:rPr>
-              <a:t>Activity 3: Question</a:t>
+              <a:t>Activity 2: Answer</a:t>
             </a:r>
             <a:endParaRPr lang="en-US" sz="3600" dirty="0"/>
           </a:p>
@@ -9966,7 +10327,7 @@
                 <a:ea typeface="Times New Roman" pitchFamily="34" charset="-122"/>
                 <a:cs typeface="Times New Roman" pitchFamily="34" charset="-120"/>
               </a:rPr>
-              <a:t>What happens to the temperature as we go deeper?</a:t>
+              <a:t>Only the crust, the thin outer layer.</a:t>
             </a:r>
             <a:endParaRPr lang="en-US" sz="4000" dirty="0"/>
           </a:p>
@@ -10084,9 +10445,48 @@
           </a:p>
         </p:txBody>
       </p:sp>
+      <p:sp>
+        <p:nvSpPr>
+          <p:cNvPr id="3" name="Text 1"/>
+          <p:cNvSpPr/>
+          <p:nvPr/>
+        </p:nvSpPr>
+        <p:spPr>
+          <a:xfrm>
+            <a:off x="457200" y="1005840"/>
+            <a:ext cx="11277295" cy="731520"/>
+          </a:xfrm>
+          <a:prstGeom prst="rect">
+            <a:avLst/>
+          </a:prstGeom>
+          <a:noFill/>
+          <a:ln/>
+        </p:spPr>
+        <p:txBody>
+          <a:bodyPr wrap="square" lIns="0" tIns="0" rIns="0" bIns="0" rtlCol="0" anchor="ctr"/>
+          <a:lstStyle/>
+          <a:p>
+            <a:pPr algn="ctr" indent="0" marL="0">
+              <a:buNone/>
+            </a:pPr>
+            <a:r>
+              <a:rPr lang="en-US" sz="3600" b="1" dirty="0">
+                <a:solidFill>
+                  <a:srgbClr val="990011"/>
+                </a:solidFill>
+                <a:latin typeface="Times New Roman" pitchFamily="34" charset="0"/>
+                <a:ea typeface="Times New Roman" pitchFamily="34" charset="-122"/>
+                <a:cs typeface="Times New Roman" pitchFamily="34" charset="-120"/>
+              </a:rPr>
+              <a:t>Activity 3</a:t>
+            </a:r>
+            <a:endParaRPr lang="en-US" sz="3600" dirty="0"/>
+          </a:p>
+        </p:txBody>
+      </p:sp>
       <p:pic>
         <p:nvPicPr>
-          <p:cNvPr id="3" name="Image 0" descr="/home/claude/f4/img/minesec_sheet.png">    </p:cNvPr>
+          <p:cNvPr id="4" name="Image 0" descr="/home/claude/f4/img/v2/earth_depth.gif">    </p:cNvPr>
           <p:cNvPicPr>
             <a:picLocks noChangeAspect="1"/>
           </p:cNvPicPr>
@@ -10100,8 +10500,8 @@
         </p:blipFill>
         <p:spPr>
           <a:xfrm>
-            <a:off x="0" y="658368"/>
-            <a:ext cx="5120640" cy="5833872"/>
+            <a:off x="629930" y="1783080"/>
+            <a:ext cx="10931835" cy="4270248"/>
           </a:xfrm>
           <a:prstGeom prst="rect">
             <a:avLst/>
@@ -10110,14 +10510,14 @@
       </p:pic>
       <p:sp>
         <p:nvSpPr>
-          <p:cNvPr id="4" name="Text 1"/>
+          <p:cNvPr id="5" name="Text 2"/>
           <p:cNvSpPr/>
           <p:nvPr/>
         </p:nvSpPr>
         <p:spPr>
           <a:xfrm>
-            <a:off x="5349240" y="1005840"/>
-            <a:ext cx="6522415" cy="731520"/>
+            <a:off x="457200" y="6089904"/>
+            <a:ext cx="11277295" cy="347472"/>
           </a:xfrm>
           <a:prstGeom prst="rect">
             <a:avLst/>
@@ -10126,68 +10526,24 @@
           <a:ln/>
         </p:spPr>
         <p:txBody>
-          <a:bodyPr wrap="square" lIns="0" tIns="0" rIns="0" bIns="0" rtlCol="0" anchor="ctr">
-            <a:normAutofit/>
-          </a:bodyPr>
+          <a:bodyPr wrap="square" lIns="0" tIns="0" rIns="0" bIns="0" rtlCol="0" anchor="ctr"/>
           <a:lstStyle/>
           <a:p>
             <a:pPr algn="ctr" indent="0" marL="0">
               <a:buNone/>
             </a:pPr>
             <a:r>
-              <a:rPr lang="en-US" sz="3600" b="1" dirty="0">
-                <a:solidFill>
-                  <a:srgbClr val="990011"/>
+              <a:rPr lang="en-US" sz="1800" i="1" dirty="0">
+                <a:solidFill>
+                  <a:srgbClr val="555555"/>
                 </a:solidFill>
                 <a:latin typeface="Times New Roman" pitchFamily="34" charset="0"/>
                 <a:ea typeface="Times New Roman" pitchFamily="34" charset="-122"/>
                 <a:cs typeface="Times New Roman" pitchFamily="34" charset="-120"/>
               </a:rPr>
-              <a:t>Activity 3: Answer</a:t>
-            </a:r>
-            <a:endParaRPr lang="en-US" sz="3600" dirty="0"/>
-          </a:p>
-        </p:txBody>
-      </p:sp>
-      <p:sp>
-        <p:nvSpPr>
-          <p:cNvPr id="5" name="Text 2"/>
-          <p:cNvSpPr/>
-          <p:nvPr/>
-        </p:nvSpPr>
-        <p:spPr>
-          <a:xfrm>
-            <a:off x="5349240" y="1783080"/>
-            <a:ext cx="6522415" cy="4663440"/>
-          </a:xfrm>
-          <a:prstGeom prst="rect">
-            <a:avLst/>
-          </a:prstGeom>
-          <a:noFill/>
-          <a:ln/>
-        </p:spPr>
-        <p:txBody>
-          <a:bodyPr wrap="square" lIns="0" tIns="0" rIns="0" bIns="0" rtlCol="0" anchor="t"/>
-          <a:lstStyle/>
-          <a:p>
-            <a:pPr algn="l" indent="0" marL="0">
-              <a:spcAft>
-                <a:spcPts val="800"/>
-              </a:spcAft>
-              <a:buNone/>
-            </a:pPr>
-            <a:r>
-              <a:rPr lang="en-US" sz="4000" dirty="0">
-                <a:solidFill>
-                  <a:srgbClr val="111111"/>
-                </a:solidFill>
-                <a:latin typeface="Times New Roman" pitchFamily="34" charset="0"/>
-                <a:ea typeface="Times New Roman" pitchFamily="34" charset="-122"/>
-                <a:cs typeface="Times New Roman" pitchFamily="34" charset="-120"/>
-              </a:rPr>
-              <a:t>It rises: about 6,000 °C at the centre.</a:t>
-            </a:r>
-            <a:endParaRPr lang="en-US" sz="4000" dirty="0"/>
+              <a:t>Animation: a journey to the centre of the Earth.</a:t>
+            </a:r>
+            <a:endParaRPr lang="en-US" sz="1800" dirty="0"/>
           </a:p>
         </p:txBody>
       </p:sp>
@@ -10297,7 +10653,7 @@
                 <a:ea typeface="Calibri" pitchFamily="34" charset="-122"/>
                 <a:cs typeface="Calibri" pitchFamily="34" charset="-120"/>
               </a:rPr>
-              <a:t>BOARD SUMMARY</a:t>
+              <a:t>2. THE MAIN LAYERS</a:t>
             </a:r>
             <a:endParaRPr lang="en-US" sz="1400" dirty="0"/>
           </a:p>
@@ -10362,7 +10718,7 @@
                 <a:ea typeface="Times New Roman" pitchFamily="34" charset="-122"/>
                 <a:cs typeface="Times New Roman" pitchFamily="34" charset="-120"/>
               </a:rPr>
-              <a:t>Board Summary</a:t>
+              <a:t>Activity 3: Question</a:t>
             </a:r>
             <a:endParaRPr lang="en-US" sz="3600" dirty="0"/>
           </a:p>
@@ -10396,7 +10752,7 @@
               <a:buNone/>
             </a:pPr>
             <a:r>
-              <a:rPr lang="en-US" sz="4000" b="1" dirty="0">
+              <a:rPr lang="en-US" sz="4000" dirty="0">
                 <a:solidFill>
                   <a:srgbClr val="111111"/>
                 </a:solidFill>
@@ -10404,47 +10760,7 @@
                 <a:ea typeface="Times New Roman" pitchFamily="34" charset="-122"/>
                 <a:cs typeface="Times New Roman" pitchFamily="34" charset="-120"/>
               </a:rPr>
-              <a:t>Topic: The Structure of the Earth: Building Processes and Impacts on Man</a:t>
-            </a:r>
-            <a:endParaRPr lang="en-US" sz="4000" dirty="0"/>
-          </a:p>
-          <a:p>
-            <a:pPr algn="l" indent="0" marL="0">
-              <a:spcAft>
-                <a:spcPts val="800"/>
-              </a:spcAft>
-              <a:buNone/>
-            </a:pPr>
-            <a:r>
-              <a:rPr lang="en-US" sz="4000" b="1" dirty="0">
-                <a:solidFill>
-                  <a:srgbClr val="111111"/>
-                </a:solidFill>
-                <a:latin typeface="Times New Roman" pitchFamily="34" charset="0"/>
-                <a:ea typeface="Times New Roman" pitchFamily="34" charset="-122"/>
-                <a:cs typeface="Times New Roman" pitchFamily="34" charset="-120"/>
-              </a:rPr>
-              <a:t>Sub-topic: Internal Structure of the Earth</a:t>
-            </a:r>
-            <a:endParaRPr lang="en-US" sz="4000" dirty="0"/>
-          </a:p>
-          <a:p>
-            <a:pPr algn="l" indent="0" marL="0">
-              <a:spcAft>
-                <a:spcPts val="800"/>
-              </a:spcAft>
-              <a:buNone/>
-            </a:pPr>
-            <a:r>
-              <a:rPr lang="en-US" sz="4000" b="1" dirty="0">
-                <a:solidFill>
-                  <a:srgbClr val="990011"/>
-                </a:solidFill>
-                <a:latin typeface="Times New Roman" pitchFamily="34" charset="0"/>
-                <a:ea typeface="Times New Roman" pitchFamily="34" charset="-122"/>
-                <a:cs typeface="Times New Roman" pitchFamily="34" charset="-120"/>
-              </a:rPr>
-              <a:t>Lesson 7: The Internal Structure of the Earth</a:t>
+              <a:t>What happens to the temperature as we go deeper into the Earth?</a:t>
             </a:r>
             <a:endParaRPr lang="en-US" sz="4000" dirty="0"/>
           </a:p>
@@ -10556,7 +10872,7 @@
                 <a:ea typeface="Calibri" pitchFamily="34" charset="-122"/>
                 <a:cs typeface="Calibri" pitchFamily="34" charset="-120"/>
               </a:rPr>
-              <a:t>BOARD SUMMARY</a:t>
+              <a:t>2. THE MAIN LAYERS</a:t>
             </a:r>
             <a:endParaRPr lang="en-US" sz="1400" dirty="0"/>
           </a:p>
@@ -10621,7 +10937,7 @@
                 <a:ea typeface="Times New Roman" pitchFamily="34" charset="-122"/>
                 <a:cs typeface="Times New Roman" pitchFamily="34" charset="-120"/>
               </a:rPr>
-              <a:t>1. Illustration of the Structure of the Earth</a:t>
+              <a:t>Activity 3: Answer</a:t>
             </a:r>
             <a:endParaRPr lang="en-US" sz="3600" dirty="0"/>
           </a:p>
@@ -10655,7 +10971,7 @@
               <a:buNone/>
             </a:pPr>
             <a:r>
-              <a:rPr lang="en-US" sz="4000" i="1" dirty="0">
+              <a:rPr lang="en-US" sz="4000" dirty="0">
                 <a:solidFill>
                   <a:srgbClr val="111111"/>
                 </a:solidFill>
@@ -10663,44 +10979,7 @@
                 <a:ea typeface="Times New Roman" pitchFamily="34" charset="-122"/>
                 <a:cs typeface="Times New Roman" pitchFamily="34" charset="-120"/>
               </a:rPr>
-              <a:t>The structure of the Earth can be illustrated as follows:</a:t>
-            </a:r>
-            <a:endParaRPr lang="en-US" sz="4000" dirty="0"/>
-          </a:p>
-          <a:p>
-            <a:pPr algn="l" indent="0" marL="0">
-              <a:spcAft>
-                <a:spcPts val="800"/>
-              </a:spcAft>
-              <a:buNone/>
-            </a:pPr>
-            <a:r>
-              <a:rPr lang="en-US" sz="4000" b="1" dirty="0">
-                <a:solidFill>
-                  <a:srgbClr val="111111"/>
-                </a:solidFill>
-                <a:latin typeface="Times New Roman" pitchFamily="34" charset="0"/>
-                <a:ea typeface="Times New Roman" pitchFamily="34" charset="-122"/>
-                <a:cs typeface="Times New Roman" pitchFamily="34" charset="-120"/>
-              </a:rPr>
-              <a:t>Circular view: </a:t>
-            </a:r>
-            <a:pPr algn="l" indent="0" marL="0">
-              <a:spcAft>
-                <a:spcPts val="800"/>
-              </a:spcAft>
-              <a:buNone/>
-            </a:pPr>
-            <a:r>
-              <a:rPr lang="en-US" sz="4000" dirty="0">
-                <a:solidFill>
-                  <a:srgbClr val="111111"/>
-                </a:solidFill>
-                <a:latin typeface="Times New Roman" pitchFamily="34" charset="0"/>
-                <a:ea typeface="Times New Roman" pitchFamily="34" charset="-122"/>
-                <a:cs typeface="Times New Roman" pitchFamily="34" charset="-120"/>
-              </a:rPr>
-              <a:t>The layers of the Earth form circles, one inside the other, like the layers of an onion.</a:t>
+              <a:t>It rises, to about 6,000 °C at the centre.</a:t>
             </a:r>
             <a:endParaRPr lang="en-US" sz="4000" dirty="0"/>
           </a:p>
@@ -11886,7 +12165,7 @@
                 <a:ea typeface="Times New Roman" pitchFamily="34" charset="-122"/>
                 <a:cs typeface="Times New Roman" pitchFamily="34" charset="-120"/>
               </a:rPr>
-              <a:t>1. Illustration of the Structure of the Earth (continued)</a:t>
+              <a:t>Board Summary</a:t>
             </a:r>
             <a:endParaRPr lang="en-US" sz="3600" dirty="0"/>
           </a:p>
@@ -11928,8 +12207,11 @@
                 <a:ea typeface="Times New Roman" pitchFamily="34" charset="-122"/>
                 <a:cs typeface="Times New Roman" pitchFamily="34" charset="-120"/>
               </a:rPr>
-              <a:t>Cross-sectional view: </a:t>
-            </a:r>
+              <a:t>Topic: The Structure of the Earth: Building Processes and Impacts on Man</a:t>
+            </a:r>
+            <a:endParaRPr lang="en-US" sz="4000" dirty="0"/>
+          </a:p>
+          <a:p>
             <a:pPr algn="l" indent="0" marL="0">
               <a:spcAft>
                 <a:spcPts val="800"/>
@@ -11937,7 +12219,7 @@
               <a:buNone/>
             </a:pPr>
             <a:r>
-              <a:rPr lang="en-US" sz="4000" dirty="0">
+              <a:rPr lang="en-US" sz="4000" b="1" dirty="0">
                 <a:solidFill>
                   <a:srgbClr val="111111"/>
                 </a:solidFill>
@@ -11945,7 +12227,27 @@
                 <a:ea typeface="Times New Roman" pitchFamily="34" charset="-122"/>
                 <a:cs typeface="Times New Roman" pitchFamily="34" charset="-120"/>
               </a:rPr>
-              <a:t>A cut through the Earth shows the crust, the mantle, the outer core and the inner core.</a:t>
+              <a:t>Sub-topic: Internal Structure of the Earth</a:t>
+            </a:r>
+            <a:endParaRPr lang="en-US" sz="4000" dirty="0"/>
+          </a:p>
+          <a:p>
+            <a:pPr algn="l" indent="0" marL="0">
+              <a:spcAft>
+                <a:spcPts val="800"/>
+              </a:spcAft>
+              <a:buNone/>
+            </a:pPr>
+            <a:r>
+              <a:rPr lang="en-US" sz="4000" b="1" dirty="0">
+                <a:solidFill>
+                  <a:srgbClr val="990011"/>
+                </a:solidFill>
+                <a:latin typeface="Times New Roman" pitchFamily="34" charset="0"/>
+                <a:ea typeface="Times New Roman" pitchFamily="34" charset="-122"/>
+                <a:cs typeface="Times New Roman" pitchFamily="34" charset="-120"/>
+              </a:rPr>
+              <a:t>Lesson 7: The Internal Structure of the Earth</a:t>
             </a:r>
             <a:endParaRPr lang="en-US" sz="4000" dirty="0"/>
           </a:p>
@@ -12063,48 +12365,9 @@
           </a:p>
         </p:txBody>
       </p:sp>
-      <p:sp>
-        <p:nvSpPr>
-          <p:cNvPr id="3" name="Text 1"/>
-          <p:cNvSpPr/>
-          <p:nvPr/>
-        </p:nvSpPr>
-        <p:spPr>
-          <a:xfrm>
-            <a:off x="457200" y="1005840"/>
-            <a:ext cx="11277295" cy="731520"/>
-          </a:xfrm>
-          <a:prstGeom prst="rect">
-            <a:avLst/>
-          </a:prstGeom>
-          <a:noFill/>
-          <a:ln/>
-        </p:spPr>
-        <p:txBody>
-          <a:bodyPr wrap="square" lIns="0" tIns="0" rIns="0" bIns="0" rtlCol="0" anchor="ctr"/>
-          <a:lstStyle/>
-          <a:p>
-            <a:pPr algn="ctr" indent="0" marL="0">
-              <a:buNone/>
-            </a:pPr>
-            <a:r>
-              <a:rPr lang="en-US" sz="3600" b="1" dirty="0">
-                <a:solidFill>
-                  <a:srgbClr val="990011"/>
-                </a:solidFill>
-                <a:latin typeface="Times New Roman" pitchFamily="34" charset="0"/>
-                <a:ea typeface="Times New Roman" pitchFamily="34" charset="-122"/>
-                <a:cs typeface="Times New Roman" pitchFamily="34" charset="-120"/>
-              </a:rPr>
-              <a:t>1. Illustration of the Structure of the Earth</a:t>
-            </a:r>
-            <a:endParaRPr lang="en-US" sz="3600" dirty="0"/>
-          </a:p>
-        </p:txBody>
-      </p:sp>
       <p:pic>
         <p:nvPicPr>
-          <p:cNvPr id="4" name="Image 0" descr="/home/claude/f4/img/v2/earth_layers_big.png">    </p:cNvPr>
+          <p:cNvPr id="3" name="Image 0" descr="/home/claude/f4/img/minesec_sheet.png">    </p:cNvPr>
           <p:cNvPicPr>
             <a:picLocks noChangeAspect="1"/>
           </p:cNvPicPr>
@@ -12118,8 +12381,8 @@
         </p:blipFill>
         <p:spPr>
           <a:xfrm>
-            <a:off x="629930" y="1783080"/>
-            <a:ext cx="10931835" cy="4270248"/>
+            <a:off x="0" y="658368"/>
+            <a:ext cx="2468880" cy="5833872"/>
           </a:xfrm>
           <a:prstGeom prst="rect">
             <a:avLst/>
@@ -12128,14 +12391,14 @@
       </p:pic>
       <p:sp>
         <p:nvSpPr>
-          <p:cNvPr id="5" name="Text 2"/>
+          <p:cNvPr id="4" name="Text 1"/>
           <p:cNvSpPr/>
           <p:nvPr/>
         </p:nvSpPr>
         <p:spPr>
           <a:xfrm>
-            <a:off x="457200" y="6089904"/>
-            <a:ext cx="11277295" cy="347472"/>
+            <a:off x="2697480" y="1005840"/>
+            <a:ext cx="9174175" cy="731520"/>
           </a:xfrm>
           <a:prstGeom prst="rect">
             <a:avLst/>
@@ -12144,24 +12407,142 @@
           <a:ln/>
         </p:spPr>
         <p:txBody>
-          <a:bodyPr wrap="square" lIns="0" tIns="0" rIns="0" bIns="0" rtlCol="0" anchor="ctr"/>
+          <a:bodyPr wrap="square" lIns="0" tIns="0" rIns="0" bIns="0" rtlCol="0" anchor="ctr">
+            <a:normAutofit/>
+          </a:bodyPr>
           <a:lstStyle/>
           <a:p>
             <a:pPr algn="ctr" indent="0" marL="0">
               <a:buNone/>
             </a:pPr>
             <a:r>
-              <a:rPr lang="en-US" sz="1800" i="1" dirty="0">
-                <a:solidFill>
-                  <a:srgbClr val="555555"/>
+              <a:rPr lang="en-US" sz="3600" b="1" dirty="0">
+                <a:solidFill>
+                  <a:srgbClr val="990011"/>
                 </a:solidFill>
                 <a:latin typeface="Times New Roman" pitchFamily="34" charset="0"/>
                 <a:ea typeface="Times New Roman" pitchFamily="34" charset="-122"/>
                 <a:cs typeface="Times New Roman" pitchFamily="34" charset="-120"/>
               </a:rPr>
-              <a:t>Illustration: the layers of the Earth</a:t>
-            </a:r>
-            <a:endParaRPr lang="en-US" sz="1800" dirty="0"/>
+              <a:t>DEFINITIONS</a:t>
+            </a:r>
+            <a:endParaRPr lang="en-US" sz="3600" dirty="0"/>
+          </a:p>
+        </p:txBody>
+      </p:sp>
+      <p:sp>
+        <p:nvSpPr>
+          <p:cNvPr id="5" name="Text 2"/>
+          <p:cNvSpPr/>
+          <p:nvPr/>
+        </p:nvSpPr>
+        <p:spPr>
+          <a:xfrm>
+            <a:off x="2697480" y="1783080"/>
+            <a:ext cx="9174175" cy="4663440"/>
+          </a:xfrm>
+          <a:prstGeom prst="rect">
+            <a:avLst/>
+          </a:prstGeom>
+          <a:noFill/>
+          <a:ln/>
+        </p:spPr>
+        <p:txBody>
+          <a:bodyPr wrap="square" lIns="0" tIns="0" rIns="0" bIns="0" rtlCol="0" anchor="t"/>
+          <a:lstStyle/>
+          <a:p>
+            <a:pPr algn="l" indent="0" marL="0">
+              <a:spcAft>
+                <a:spcPts val="800"/>
+              </a:spcAft>
+              <a:buNone/>
+            </a:pPr>
+            <a:r>
+              <a:rPr lang="en-US" sz="4000" i="1" dirty="0">
+                <a:solidFill>
+                  <a:srgbClr val="111111"/>
+                </a:solidFill>
+                <a:latin typeface="Times New Roman" pitchFamily="34" charset="0"/>
+                <a:ea typeface="Times New Roman" pitchFamily="34" charset="-122"/>
+                <a:cs typeface="Times New Roman" pitchFamily="34" charset="-120"/>
+              </a:rPr>
+              <a:t>The key terms of this lesson are defined as follows:</a:t>
+            </a:r>
+            <a:endParaRPr lang="en-US" sz="4000" dirty="0"/>
+          </a:p>
+          <a:p>
+            <a:pPr algn="l" indent="0" marL="0">
+              <a:spcAft>
+                <a:spcPts val="800"/>
+              </a:spcAft>
+              <a:buNone/>
+            </a:pPr>
+            <a:r>
+              <a:rPr lang="en-US" sz="4000" b="1" dirty="0">
+                <a:solidFill>
+                  <a:srgbClr val="111111"/>
+                </a:solidFill>
+                <a:latin typeface="Times New Roman" pitchFamily="34" charset="0"/>
+                <a:ea typeface="Times New Roman" pitchFamily="34" charset="-122"/>
+                <a:cs typeface="Times New Roman" pitchFamily="34" charset="-120"/>
+              </a:rPr>
+              <a:t>Crust: </a:t>
+            </a:r>
+            <a:pPr algn="l" indent="0" marL="0">
+              <a:spcAft>
+                <a:spcPts val="800"/>
+              </a:spcAft>
+              <a:buNone/>
+            </a:pPr>
+            <a:r>
+              <a:rPr lang="en-US" sz="4000" dirty="0">
+                <a:solidFill>
+                  <a:srgbClr val="111111"/>
+                </a:solidFill>
+                <a:latin typeface="Times New Roman" pitchFamily="34" charset="0"/>
+                <a:ea typeface="Times New Roman" pitchFamily="34" charset="-122"/>
+                <a:cs typeface="Times New Roman" pitchFamily="34" charset="-120"/>
+              </a:rPr>
+              <a:t>It is the thin, solid outer layer of the Earth, on which we live.</a:t>
+            </a:r>
+            <a:endParaRPr lang="en-US" sz="4000" dirty="0"/>
+          </a:p>
+          <a:p>
+            <a:pPr algn="l" indent="0" marL="0">
+              <a:spcAft>
+                <a:spcPts val="800"/>
+              </a:spcAft>
+              <a:buNone/>
+            </a:pPr>
+            <a:r>
+              <a:rPr lang="en-US" sz="4000" b="1" dirty="0">
+                <a:solidFill>
+                  <a:srgbClr val="111111"/>
+                </a:solidFill>
+                <a:latin typeface="Times New Roman" pitchFamily="34" charset="0"/>
+                <a:ea typeface="Times New Roman" pitchFamily="34" charset="-122"/>
+                <a:cs typeface="Times New Roman" pitchFamily="34" charset="-120"/>
+              </a:rPr>
+              <a:t>Mantle: </a:t>
+            </a:r>
+            <a:pPr algn="l" indent="0" marL="0">
+              <a:spcAft>
+                <a:spcPts val="800"/>
+              </a:spcAft>
+              <a:buNone/>
+            </a:pPr>
+            <a:r>
+              <a:rPr lang="en-US" sz="4000" dirty="0">
+                <a:solidFill>
+                  <a:srgbClr val="111111"/>
+                </a:solidFill>
+                <a:latin typeface="Times New Roman" pitchFamily="34" charset="0"/>
+                <a:ea typeface="Times New Roman" pitchFamily="34" charset="-122"/>
+                <a:cs typeface="Times New Roman" pitchFamily="34" charset="-120"/>
+              </a:rPr>
+              <a:t>It is the thick layer of very hot rock between the crust and the core.</a:t>
+            </a:r>
+            <a:endParaRPr lang="en-US" sz="4000" dirty="0"/>
           </a:p>
         </p:txBody>
       </p:sp>
@@ -12294,7 +12675,7 @@
         <p:spPr>
           <a:xfrm>
             <a:off x="0" y="658368"/>
-            <a:ext cx="3840480" cy="5833872"/>
+            <a:ext cx="5120640" cy="5833872"/>
           </a:xfrm>
           <a:prstGeom prst="rect">
             <a:avLst/>
@@ -12309,8 +12690,8 @@
         </p:nvSpPr>
         <p:spPr>
           <a:xfrm>
-            <a:off x="4069080" y="1005840"/>
-            <a:ext cx="7802575" cy="731520"/>
+            <a:off x="5349240" y="1005840"/>
+            <a:ext cx="6522415" cy="731520"/>
           </a:xfrm>
           <a:prstGeom prst="rect">
             <a:avLst/>
@@ -12336,7 +12717,7 @@
                 <a:ea typeface="Times New Roman" pitchFamily="34" charset="-122"/>
                 <a:cs typeface="Times New Roman" pitchFamily="34" charset="-120"/>
               </a:rPr>
-              <a:t>2. The Main Layers</a:t>
+              <a:t>DEFINITIONS (continued)</a:t>
             </a:r>
             <a:endParaRPr lang="en-US" sz="3600" dirty="0"/>
           </a:p>
@@ -12350,8 +12731,8 @@
         </p:nvSpPr>
         <p:spPr>
           <a:xfrm>
-            <a:off x="4069080" y="1783080"/>
-            <a:ext cx="7802575" cy="4663440"/>
+            <a:off x="5349240" y="1783080"/>
+            <a:ext cx="6522415" cy="4663440"/>
           </a:xfrm>
           <a:prstGeom prst="rect">
             <a:avLst/>
@@ -12370,7 +12751,7 @@
               <a:buNone/>
             </a:pPr>
             <a:r>
-              <a:rPr lang="en-US" sz="4000" i="1" dirty="0">
+              <a:rPr lang="en-US" sz="4000" b="1" dirty="0">
                 <a:solidFill>
                   <a:srgbClr val="111111"/>
                 </a:solidFill>
@@ -12378,11 +12759,8 @@
                 <a:ea typeface="Times New Roman" pitchFamily="34" charset="-122"/>
                 <a:cs typeface="Times New Roman" pitchFamily="34" charset="-120"/>
               </a:rPr>
-              <a:t>The main layers of the Earth are described as follows:</a:t>
-            </a:r>
-            <a:endParaRPr lang="en-US" sz="4000" dirty="0"/>
-          </a:p>
-          <a:p>
+              <a:t>Core: </a:t>
+            </a:r>
             <a:pPr algn="l" indent="0" marL="0">
               <a:spcAft>
                 <a:spcPts val="800"/>
@@ -12390,7 +12768,7 @@
               <a:buNone/>
             </a:pPr>
             <a:r>
-              <a:rPr lang="en-US" sz="4000" b="1" dirty="0">
+              <a:rPr lang="en-US" sz="4000" dirty="0">
                 <a:solidFill>
                   <a:srgbClr val="111111"/>
                 </a:solidFill>
@@ -12398,61 +12776,7 @@
                 <a:ea typeface="Times New Roman" pitchFamily="34" charset="-122"/>
                 <a:cs typeface="Times New Roman" pitchFamily="34" charset="-120"/>
               </a:rPr>
-              <a:t>Crust: </a:t>
-            </a:r>
-            <a:pPr algn="l" indent="0" marL="0">
-              <a:spcAft>
-                <a:spcPts val="800"/>
-              </a:spcAft>
-              <a:buNone/>
-            </a:pPr>
-            <a:r>
-              <a:rPr lang="en-US" sz="4000" dirty="0">
-                <a:solidFill>
-                  <a:srgbClr val="111111"/>
-                </a:solidFill>
-                <a:latin typeface="Times New Roman" pitchFamily="34" charset="0"/>
-                <a:ea typeface="Times New Roman" pitchFamily="34" charset="-122"/>
-                <a:cs typeface="Times New Roman" pitchFamily="34" charset="-120"/>
-              </a:rPr>
-              <a:t>It is the thin, solid outer layer of rock on which we live.</a:t>
-            </a:r>
-            <a:endParaRPr lang="en-US" sz="4000" dirty="0"/>
-          </a:p>
-          <a:p>
-            <a:pPr algn="l" indent="0" marL="0">
-              <a:spcAft>
-                <a:spcPts val="800"/>
-              </a:spcAft>
-              <a:buNone/>
-            </a:pPr>
-            <a:r>
-              <a:rPr lang="en-US" sz="4000" b="1" dirty="0">
-                <a:solidFill>
-                  <a:srgbClr val="111111"/>
-                </a:solidFill>
-                <a:latin typeface="Times New Roman" pitchFamily="34" charset="0"/>
-                <a:ea typeface="Times New Roman" pitchFamily="34" charset="-122"/>
-                <a:cs typeface="Times New Roman" pitchFamily="34" charset="-120"/>
-              </a:rPr>
-              <a:t>Mantle: </a:t>
-            </a:r>
-            <a:pPr algn="l" indent="0" marL="0">
-              <a:spcAft>
-                <a:spcPts val="800"/>
-              </a:spcAft>
-              <a:buNone/>
-            </a:pPr>
-            <a:r>
-              <a:rPr lang="en-US" sz="4000" dirty="0">
-                <a:solidFill>
-                  <a:srgbClr val="111111"/>
-                </a:solidFill>
-                <a:latin typeface="Times New Roman" pitchFamily="34" charset="0"/>
-                <a:ea typeface="Times New Roman" pitchFamily="34" charset="-122"/>
-                <a:cs typeface="Times New Roman" pitchFamily="34" charset="-120"/>
-              </a:rPr>
-              <a:t>It is a thick layer of very hot rock, about 2,900 km thick, under the crust.</a:t>
+              <a:t>It is the central part of the Earth, made mainly of iron and nickel.</a:t>
             </a:r>
             <a:endParaRPr lang="en-US" sz="4000" dirty="0"/>
           </a:p>
@@ -12570,9 +12894,129 @@
           </a:p>
         </p:txBody>
       </p:sp>
+      <p:sp>
+        <p:nvSpPr>
+          <p:cNvPr id="3" name="Text 1"/>
+          <p:cNvSpPr/>
+          <p:nvPr/>
+        </p:nvSpPr>
+        <p:spPr>
+          <a:xfrm>
+            <a:off x="365760" y="1005840"/>
+            <a:ext cx="11460175" cy="731520"/>
+          </a:xfrm>
+          <a:prstGeom prst="rect">
+            <a:avLst/>
+          </a:prstGeom>
+          <a:noFill/>
+          <a:ln/>
+        </p:spPr>
+        <p:txBody>
+          <a:bodyPr wrap="square" lIns="0" tIns="0" rIns="0" bIns="0" rtlCol="0" anchor="ctr">
+            <a:normAutofit/>
+          </a:bodyPr>
+          <a:lstStyle/>
+          <a:p>
+            <a:pPr algn="ctr" indent="0" marL="0">
+              <a:buNone/>
+            </a:pPr>
+            <a:r>
+              <a:rPr lang="en-US" sz="3600" b="1" dirty="0">
+                <a:solidFill>
+                  <a:srgbClr val="990011"/>
+                </a:solidFill>
+                <a:latin typeface="Times New Roman" pitchFamily="34" charset="0"/>
+                <a:ea typeface="Times New Roman" pitchFamily="34" charset="-122"/>
+                <a:cs typeface="Times New Roman" pitchFamily="34" charset="-120"/>
+              </a:rPr>
+              <a:t>1. Illustrations of the Structure of the Earth</a:t>
+            </a:r>
+            <a:endParaRPr lang="en-US" sz="3600" dirty="0"/>
+          </a:p>
+        </p:txBody>
+      </p:sp>
+      <p:sp>
+        <p:nvSpPr>
+          <p:cNvPr id="4" name="Text 2"/>
+          <p:cNvSpPr/>
+          <p:nvPr/>
+        </p:nvSpPr>
+        <p:spPr>
+          <a:xfrm>
+            <a:off x="365760" y="1783080"/>
+            <a:ext cx="4846320" cy="4617720"/>
+          </a:xfrm>
+          <a:prstGeom prst="rect">
+            <a:avLst/>
+          </a:prstGeom>
+          <a:noFill/>
+          <a:ln/>
+        </p:spPr>
+        <p:txBody>
+          <a:bodyPr wrap="square" lIns="0" tIns="0" rIns="0" bIns="0" rtlCol="0" anchor="t"/>
+          <a:lstStyle/>
+          <a:p>
+            <a:pPr algn="l" indent="0" marL="0">
+              <a:spcAft>
+                <a:spcPts val="800"/>
+              </a:spcAft>
+              <a:buNone/>
+            </a:pPr>
+            <a:r>
+              <a:rPr lang="en-US" sz="3600" i="1" dirty="0">
+                <a:solidFill>
+                  <a:srgbClr val="111111"/>
+                </a:solidFill>
+                <a:latin typeface="Times New Roman" pitchFamily="34" charset="0"/>
+                <a:ea typeface="Times New Roman" pitchFamily="34" charset="-122"/>
+                <a:cs typeface="Times New Roman" pitchFamily="34" charset="-120"/>
+              </a:rPr>
+              <a:t>The structure of the Earth is illustrated in two ways:</a:t>
+            </a:r>
+            <a:endParaRPr lang="en-US" sz="3600" dirty="0"/>
+          </a:p>
+          <a:p>
+            <a:pPr algn="l" indent="0" marL="0">
+              <a:spcAft>
+                <a:spcPts val="800"/>
+              </a:spcAft>
+              <a:buNone/>
+            </a:pPr>
+            <a:r>
+              <a:rPr lang="en-US" sz="3600" b="1" dirty="0">
+                <a:solidFill>
+                  <a:srgbClr val="111111"/>
+                </a:solidFill>
+                <a:latin typeface="Times New Roman" pitchFamily="34" charset="0"/>
+                <a:ea typeface="Times New Roman" pitchFamily="34" charset="-122"/>
+                <a:cs typeface="Times New Roman" pitchFamily="34" charset="-120"/>
+              </a:rPr>
+              <a:t>Circular view: </a:t>
+            </a:r>
+            <a:pPr algn="l" indent="0" marL="0">
+              <a:spcAft>
+                <a:spcPts val="800"/>
+              </a:spcAft>
+              <a:buNone/>
+            </a:pPr>
+            <a:r>
+              <a:rPr lang="en-US" sz="3600" dirty="0">
+                <a:solidFill>
+                  <a:srgbClr val="111111"/>
+                </a:solidFill>
+                <a:latin typeface="Times New Roman" pitchFamily="34" charset="0"/>
+                <a:ea typeface="Times New Roman" pitchFamily="34" charset="-122"/>
+                <a:cs typeface="Times New Roman" pitchFamily="34" charset="-120"/>
+              </a:rPr>
+              <a:t>The layers form circles, one inside the other, like the layers of an onion.</a:t>
+            </a:r>
+            <a:endParaRPr lang="en-US" sz="3600" dirty="0"/>
+          </a:p>
+        </p:txBody>
+      </p:sp>
       <p:pic>
         <p:nvPicPr>
-          <p:cNvPr id="3" name="Image 0" descr="/home/claude/f4/img/minesec_sheet.png">    </p:cNvPr>
+          <p:cNvPr id="5" name="Image 0" descr="/home/claude/f4/img/v2/earth_layers_big.png">    </p:cNvPr>
           <p:cNvPicPr>
             <a:picLocks noChangeAspect="1"/>
           </p:cNvPicPr>
@@ -12586,8 +13030,8 @@
         </p:blipFill>
         <p:spPr>
           <a:xfrm>
-            <a:off x="0" y="658368"/>
-            <a:ext cx="5120640" cy="5833872"/>
+            <a:off x="5349240" y="2617506"/>
+            <a:ext cx="6659575" cy="2601397"/>
           </a:xfrm>
           <a:prstGeom prst="rect">
             <a:avLst/>
@@ -12596,14 +13040,14 @@
       </p:pic>
       <p:sp>
         <p:nvSpPr>
-          <p:cNvPr id="4" name="Text 1"/>
+          <p:cNvPr id="6" name="Text 3"/>
           <p:cNvSpPr/>
           <p:nvPr/>
         </p:nvSpPr>
         <p:spPr>
           <a:xfrm>
-            <a:off x="5349240" y="1005840"/>
-            <a:ext cx="6522415" cy="731520"/>
+            <a:off x="5349240" y="6089904"/>
+            <a:ext cx="6659575" cy="347472"/>
           </a:xfrm>
           <a:prstGeom prst="rect">
             <a:avLst/>
@@ -12612,122 +13056,24 @@
           <a:ln/>
         </p:spPr>
         <p:txBody>
-          <a:bodyPr wrap="square" lIns="0" tIns="0" rIns="0" bIns="0" rtlCol="0" anchor="ctr">
-            <a:normAutofit/>
-          </a:bodyPr>
+          <a:bodyPr wrap="square" lIns="0" tIns="0" rIns="0" bIns="0" rtlCol="0" anchor="ctr"/>
           <a:lstStyle/>
           <a:p>
             <a:pPr algn="ctr" indent="0" marL="0">
               <a:buNone/>
             </a:pPr>
             <a:r>
-              <a:rPr lang="en-US" sz="3600" b="1" dirty="0">
-                <a:solidFill>
-                  <a:srgbClr val="990011"/>
+              <a:rPr lang="en-US" sz="1600" i="1" dirty="0">
+                <a:solidFill>
+                  <a:srgbClr val="555555"/>
                 </a:solidFill>
                 <a:latin typeface="Times New Roman" pitchFamily="34" charset="0"/>
                 <a:ea typeface="Times New Roman" pitchFamily="34" charset="-122"/>
                 <a:cs typeface="Times New Roman" pitchFamily="34" charset="-120"/>
               </a:rPr>
-              <a:t>2. The Main Layers (continued)</a:t>
-            </a:r>
-            <a:endParaRPr lang="en-US" sz="3600" dirty="0"/>
-          </a:p>
-        </p:txBody>
-      </p:sp>
-      <p:sp>
-        <p:nvSpPr>
-          <p:cNvPr id="5" name="Text 2"/>
-          <p:cNvSpPr/>
-          <p:nvPr/>
-        </p:nvSpPr>
-        <p:spPr>
-          <a:xfrm>
-            <a:off x="5349240" y="1783080"/>
-            <a:ext cx="6522415" cy="4663440"/>
-          </a:xfrm>
-          <a:prstGeom prst="rect">
-            <a:avLst/>
-          </a:prstGeom>
-          <a:noFill/>
-          <a:ln/>
-        </p:spPr>
-        <p:txBody>
-          <a:bodyPr wrap="square" lIns="0" tIns="0" rIns="0" bIns="0" rtlCol="0" anchor="t"/>
-          <a:lstStyle/>
-          <a:p>
-            <a:pPr algn="l" indent="0" marL="0">
-              <a:spcAft>
-                <a:spcPts val="800"/>
-              </a:spcAft>
-              <a:buNone/>
-            </a:pPr>
-            <a:r>
-              <a:rPr lang="en-US" sz="4000" b="1" dirty="0">
-                <a:solidFill>
-                  <a:srgbClr val="111111"/>
-                </a:solidFill>
-                <a:latin typeface="Times New Roman" pitchFamily="34" charset="0"/>
-                <a:ea typeface="Times New Roman" pitchFamily="34" charset="-122"/>
-                <a:cs typeface="Times New Roman" pitchFamily="34" charset="-120"/>
-              </a:rPr>
-              <a:t>Outer core: </a:t>
-            </a:r>
-            <a:pPr algn="l" indent="0" marL="0">
-              <a:spcAft>
-                <a:spcPts val="800"/>
-              </a:spcAft>
-              <a:buNone/>
-            </a:pPr>
-            <a:r>
-              <a:rPr lang="en-US" sz="4000" dirty="0">
-                <a:solidFill>
-                  <a:srgbClr val="111111"/>
-                </a:solidFill>
-                <a:latin typeface="Times New Roman" pitchFamily="34" charset="0"/>
-                <a:ea typeface="Times New Roman" pitchFamily="34" charset="-122"/>
-                <a:cs typeface="Times New Roman" pitchFamily="34" charset="-120"/>
-              </a:rPr>
-              <a:t>It is a layer of liquid iron and nickel around the inner core.</a:t>
-            </a:r>
-            <a:endParaRPr lang="en-US" sz="4000" dirty="0"/>
-          </a:p>
-          <a:p>
-            <a:pPr algn="l" indent="0" marL="0">
-              <a:spcAft>
-                <a:spcPts val="800"/>
-              </a:spcAft>
-              <a:buNone/>
-            </a:pPr>
-            <a:r>
-              <a:rPr lang="en-US" sz="4000" b="1" dirty="0">
-                <a:solidFill>
-                  <a:srgbClr val="111111"/>
-                </a:solidFill>
-                <a:latin typeface="Times New Roman" pitchFamily="34" charset="0"/>
-                <a:ea typeface="Times New Roman" pitchFamily="34" charset="-122"/>
-                <a:cs typeface="Times New Roman" pitchFamily="34" charset="-120"/>
-              </a:rPr>
-              <a:t>Inner core: </a:t>
-            </a:r>
-            <a:pPr algn="l" indent="0" marL="0">
-              <a:spcAft>
-                <a:spcPts val="800"/>
-              </a:spcAft>
-              <a:buNone/>
-            </a:pPr>
-            <a:r>
-              <a:rPr lang="en-US" sz="4000" dirty="0">
-                <a:solidFill>
-                  <a:srgbClr val="111111"/>
-                </a:solidFill>
-                <a:latin typeface="Times New Roman" pitchFamily="34" charset="0"/>
-                <a:ea typeface="Times New Roman" pitchFamily="34" charset="-122"/>
-                <a:cs typeface="Times New Roman" pitchFamily="34" charset="-120"/>
-              </a:rPr>
-              <a:t>It is the solid centre of the Earth, made of iron and nickel at about 6,000 °C.</a:t>
-            </a:r>
-            <a:endParaRPr lang="en-US" sz="4000" dirty="0"/>
+              <a:t>Illustration: the layers of the Earth (circular view)</a:t>
+            </a:r>
+            <a:endParaRPr lang="en-US" sz="1600" dirty="0"/>
           </a:p>
         </p:txBody>
       </p:sp>
@@ -12837,15 +13183,115 @@
                 <a:ea typeface="Calibri" pitchFamily="34" charset="-122"/>
                 <a:cs typeface="Calibri" pitchFamily="34" charset="-120"/>
               </a:rPr>
-              <a:t>FORMATIVE EVALUATION</a:t>
+              <a:t>BOARD SUMMARY</a:t>
             </a:r>
             <a:endParaRPr lang="en-US" sz="1400" dirty="0"/>
+          </a:p>
+        </p:txBody>
+      </p:sp>
+      <p:sp>
+        <p:nvSpPr>
+          <p:cNvPr id="3" name="Text 1"/>
+          <p:cNvSpPr/>
+          <p:nvPr/>
+        </p:nvSpPr>
+        <p:spPr>
+          <a:xfrm>
+            <a:off x="365760" y="1005840"/>
+            <a:ext cx="11460175" cy="731520"/>
+          </a:xfrm>
+          <a:prstGeom prst="rect">
+            <a:avLst/>
+          </a:prstGeom>
+          <a:noFill/>
+          <a:ln/>
+        </p:spPr>
+        <p:txBody>
+          <a:bodyPr wrap="square" lIns="0" tIns="0" rIns="0" bIns="0" rtlCol="0" anchor="ctr">
+            <a:normAutofit/>
+          </a:bodyPr>
+          <a:lstStyle/>
+          <a:p>
+            <a:pPr algn="ctr" indent="0" marL="0">
+              <a:buNone/>
+            </a:pPr>
+            <a:r>
+              <a:rPr lang="en-US" sz="3600" b="1" dirty="0">
+                <a:solidFill>
+                  <a:srgbClr val="990011"/>
+                </a:solidFill>
+                <a:latin typeface="Times New Roman" pitchFamily="34" charset="0"/>
+                <a:ea typeface="Times New Roman" pitchFamily="34" charset="-122"/>
+                <a:cs typeface="Times New Roman" pitchFamily="34" charset="-120"/>
+              </a:rPr>
+              <a:t>1. Illustrations of the Structure of the Earth</a:t>
+            </a:r>
+            <a:endParaRPr lang="en-US" sz="3600" dirty="0"/>
+          </a:p>
+        </p:txBody>
+      </p:sp>
+      <p:sp>
+        <p:nvSpPr>
+          <p:cNvPr id="4" name="Text 2"/>
+          <p:cNvSpPr/>
+          <p:nvPr/>
+        </p:nvSpPr>
+        <p:spPr>
+          <a:xfrm>
+            <a:off x="365760" y="1783080"/>
+            <a:ext cx="4846320" cy="4617720"/>
+          </a:xfrm>
+          <a:prstGeom prst="rect">
+            <a:avLst/>
+          </a:prstGeom>
+          <a:noFill/>
+          <a:ln/>
+        </p:spPr>
+        <p:txBody>
+          <a:bodyPr wrap="square" lIns="0" tIns="0" rIns="0" bIns="0" rtlCol="0" anchor="t"/>
+          <a:lstStyle/>
+          <a:p>
+            <a:pPr algn="l" indent="0" marL="0">
+              <a:spcAft>
+                <a:spcPts val="800"/>
+              </a:spcAft>
+              <a:buNone/>
+            </a:pPr>
+            <a:r>
+              <a:rPr lang="en-US" sz="3600" b="1" dirty="0">
+                <a:solidFill>
+                  <a:srgbClr val="111111"/>
+                </a:solidFill>
+                <a:latin typeface="Times New Roman" pitchFamily="34" charset="0"/>
+                <a:ea typeface="Times New Roman" pitchFamily="34" charset="-122"/>
+                <a:cs typeface="Times New Roman" pitchFamily="34" charset="-120"/>
+              </a:rPr>
+              <a:t>Cross-sectional view: </a:t>
+            </a:r>
+            <a:pPr algn="l" indent="0" marL="0">
+              <a:spcAft>
+                <a:spcPts val="800"/>
+              </a:spcAft>
+              <a:buNone/>
+            </a:pPr>
+            <a:r>
+              <a:rPr lang="en-US" sz="3600" dirty="0">
+                <a:solidFill>
+                  <a:srgbClr val="111111"/>
+                </a:solidFill>
+                <a:latin typeface="Times New Roman" pitchFamily="34" charset="0"/>
+                <a:ea typeface="Times New Roman" pitchFamily="34" charset="-122"/>
+                <a:cs typeface="Times New Roman" pitchFamily="34" charset="-120"/>
+              </a:rPr>
+              <a:t>A cut through the Earth shows the crust, the mantle, the outer core and the inner core from the surface to the centre.</a:t>
+            </a:r>
+            <a:endParaRPr lang="en-US" sz="3600" dirty="0"/>
           </a:p>
         </p:txBody>
       </p:sp>
       <p:pic>
         <p:nvPicPr>
-          <p:cNvPr id="3" name="Image 0" descr="/home/claude/f4/img/minesec_sheet.png">    </p:cNvPr>
+          <p:cNvPr id="5" name="Image 0" descr="/home/claude/f4/img/earth_structure.png">    </p:cNvPr>
           <p:cNvPicPr>
             <a:picLocks noChangeAspect="1"/>
           </p:cNvPicPr>
@@ -12859,8 +13305,8 @@
         </p:blipFill>
         <p:spPr>
           <a:xfrm>
-            <a:off x="0" y="658368"/>
-            <a:ext cx="5120640" cy="5833872"/>
+            <a:off x="5349240" y="1930246"/>
+            <a:ext cx="6659575" cy="3975917"/>
           </a:xfrm>
           <a:prstGeom prst="rect">
             <a:avLst/>
@@ -12869,14 +13315,14 @@
       </p:pic>
       <p:sp>
         <p:nvSpPr>
-          <p:cNvPr id="4" name="Text 1"/>
+          <p:cNvPr id="6" name="Text 3"/>
           <p:cNvSpPr/>
           <p:nvPr/>
         </p:nvSpPr>
         <p:spPr>
           <a:xfrm>
-            <a:off x="5349240" y="1005840"/>
-            <a:ext cx="6522415" cy="731520"/>
+            <a:off x="5349240" y="6089904"/>
+            <a:ext cx="6659575" cy="347472"/>
           </a:xfrm>
           <a:prstGeom prst="rect">
             <a:avLst/>
@@ -12885,68 +13331,24 @@
           <a:ln/>
         </p:spPr>
         <p:txBody>
-          <a:bodyPr wrap="square" lIns="0" tIns="0" rIns="0" bIns="0" rtlCol="0" anchor="ctr">
-            <a:normAutofit/>
-          </a:bodyPr>
+          <a:bodyPr wrap="square" lIns="0" tIns="0" rIns="0" bIns="0" rtlCol="0" anchor="ctr"/>
           <a:lstStyle/>
           <a:p>
             <a:pPr algn="ctr" indent="0" marL="0">
               <a:buNone/>
             </a:pPr>
             <a:r>
-              <a:rPr lang="en-US" sz="3600" b="1" dirty="0">
-                <a:solidFill>
-                  <a:srgbClr val="990011"/>
+              <a:rPr lang="en-US" sz="1600" i="1" dirty="0">
+                <a:solidFill>
+                  <a:srgbClr val="555555"/>
                 </a:solidFill>
                 <a:latin typeface="Times New Roman" pitchFamily="34" charset="0"/>
                 <a:ea typeface="Times New Roman" pitchFamily="34" charset="-122"/>
                 <a:cs typeface="Times New Roman" pitchFamily="34" charset="-120"/>
               </a:rPr>
-              <a:t>Evaluation 1</a:t>
-            </a:r>
-            <a:endParaRPr lang="en-US" sz="3600" dirty="0"/>
-          </a:p>
-        </p:txBody>
-      </p:sp>
-      <p:sp>
-        <p:nvSpPr>
-          <p:cNvPr id="5" name="Text 2"/>
-          <p:cNvSpPr/>
-          <p:nvPr/>
-        </p:nvSpPr>
-        <p:spPr>
-          <a:xfrm>
-            <a:off x="5349240" y="1783080"/>
-            <a:ext cx="6522415" cy="4663440"/>
-          </a:xfrm>
-          <a:prstGeom prst="rect">
-            <a:avLst/>
-          </a:prstGeom>
-          <a:noFill/>
-          <a:ln/>
-        </p:spPr>
-        <p:txBody>
-          <a:bodyPr wrap="square" lIns="0" tIns="0" rIns="0" bIns="0" rtlCol="0" anchor="t"/>
-          <a:lstStyle/>
-          <a:p>
-            <a:pPr algn="l" indent="0" marL="0">
-              <a:spcAft>
-                <a:spcPts val="800"/>
-              </a:spcAft>
-              <a:buNone/>
-            </a:pPr>
-            <a:r>
-              <a:rPr lang="en-US" sz="4000" dirty="0">
-                <a:solidFill>
-                  <a:srgbClr val="111111"/>
-                </a:solidFill>
-                <a:latin typeface="Times New Roman" pitchFamily="34" charset="0"/>
-                <a:ea typeface="Times New Roman" pitchFamily="34" charset="-122"/>
-                <a:cs typeface="Times New Roman" pitchFamily="34" charset="-120"/>
-              </a:rPr>
-              <a:t>Name the layer on which we live.</a:t>
-            </a:r>
-            <a:endParaRPr lang="en-US" sz="4000" dirty="0"/>
+              <a:t>Illustration: the internal structure of the Earth (cross-section)</a:t>
+            </a:r>
+            <a:endParaRPr lang="en-US" sz="1600" dirty="0"/>
           </a:p>
         </p:txBody>
       </p:sp>
@@ -13056,7 +13458,7 @@
                 <a:ea typeface="Calibri" pitchFamily="34" charset="-122"/>
                 <a:cs typeface="Calibri" pitchFamily="34" charset="-120"/>
               </a:rPr>
-              <a:t>FORMATIVE EVALUATION</a:t>
+              <a:t>BOARD SUMMARY</a:t>
             </a:r>
             <a:endParaRPr lang="en-US" sz="1400" dirty="0"/>
           </a:p>
@@ -13121,7 +13523,7 @@
                 <a:ea typeface="Times New Roman" pitchFamily="34" charset="-122"/>
                 <a:cs typeface="Times New Roman" pitchFamily="34" charset="-120"/>
               </a:rPr>
-              <a:t>Expected Answer</a:t>
+              <a:t>2. Brief Description of the Main Layers</a:t>
             </a:r>
             <a:endParaRPr lang="en-US" sz="3600" dirty="0"/>
           </a:p>
@@ -13155,7 +13557,7 @@
               <a:buNone/>
             </a:pPr>
             <a:r>
-              <a:rPr lang="en-US" sz="4000" dirty="0">
+              <a:rPr lang="en-US" sz="4000" i="1" dirty="0">
                 <a:solidFill>
                   <a:srgbClr val="111111"/>
                 </a:solidFill>
@@ -13163,7 +13565,44 @@
                 <a:ea typeface="Times New Roman" pitchFamily="34" charset="-122"/>
                 <a:cs typeface="Times New Roman" pitchFamily="34" charset="-120"/>
               </a:rPr>
-              <a:t>The crust.</a:t>
+              <a:t>The main layers of the Earth are described as follows:</a:t>
+            </a:r>
+            <a:endParaRPr lang="en-US" sz="4000" dirty="0"/>
+          </a:p>
+          <a:p>
+            <a:pPr algn="l" indent="0" marL="0">
+              <a:spcAft>
+                <a:spcPts val="800"/>
+              </a:spcAft>
+              <a:buNone/>
+            </a:pPr>
+            <a:r>
+              <a:rPr lang="en-US" sz="4000" b="1" dirty="0">
+                <a:solidFill>
+                  <a:srgbClr val="111111"/>
+                </a:solidFill>
+                <a:latin typeface="Times New Roman" pitchFamily="34" charset="0"/>
+                <a:ea typeface="Times New Roman" pitchFamily="34" charset="-122"/>
+                <a:cs typeface="Times New Roman" pitchFamily="34" charset="-120"/>
+              </a:rPr>
+              <a:t>The crust: </a:t>
+            </a:r>
+            <a:pPr algn="l" indent="0" marL="0">
+              <a:spcAft>
+                <a:spcPts val="800"/>
+              </a:spcAft>
+              <a:buNone/>
+            </a:pPr>
+            <a:r>
+              <a:rPr lang="en-US" sz="4000" dirty="0">
+                <a:solidFill>
+                  <a:srgbClr val="111111"/>
+                </a:solidFill>
+                <a:latin typeface="Times New Roman" pitchFamily="34" charset="0"/>
+                <a:ea typeface="Times New Roman" pitchFamily="34" charset="-122"/>
+                <a:cs typeface="Times New Roman" pitchFamily="34" charset="-120"/>
+              </a:rPr>
+              <a:t>It is 5 to 10 km thick under the oceans and 30 to 70 km thick under the continents. It is made of solid rock.</a:t>
             </a:r>
             <a:endParaRPr lang="en-US" sz="4000" dirty="0"/>
           </a:p>
@@ -13275,7 +13714,7 @@
                 <a:ea typeface="Calibri" pitchFamily="34" charset="-122"/>
                 <a:cs typeface="Calibri" pitchFamily="34" charset="-120"/>
               </a:rPr>
-              <a:t>FORMATIVE EVALUATION</a:t>
+              <a:t>BOARD SUMMARY</a:t>
             </a:r>
             <a:endParaRPr lang="en-US" sz="1400" dirty="0"/>
           </a:p>
@@ -13298,7 +13737,7 @@
         <p:spPr>
           <a:xfrm>
             <a:off x="0" y="658368"/>
-            <a:ext cx="5120640" cy="5833872"/>
+            <a:ext cx="3840480" cy="5833872"/>
           </a:xfrm>
           <a:prstGeom prst="rect">
             <a:avLst/>
@@ -13313,8 +13752,8 @@
         </p:nvSpPr>
         <p:spPr>
           <a:xfrm>
-            <a:off x="5349240" y="1005840"/>
-            <a:ext cx="6522415" cy="731520"/>
+            <a:off x="4069080" y="1005840"/>
+            <a:ext cx="7802575" cy="731520"/>
           </a:xfrm>
           <a:prstGeom prst="rect">
             <a:avLst/>
@@ -13340,7 +13779,7 @@
                 <a:ea typeface="Times New Roman" pitchFamily="34" charset="-122"/>
                 <a:cs typeface="Times New Roman" pitchFamily="34" charset="-120"/>
               </a:rPr>
-              <a:t>Evaluation 2</a:t>
+              <a:t>2. Brief Description of the Main Layers (continued)</a:t>
             </a:r>
             <a:endParaRPr lang="en-US" sz="3600" dirty="0"/>
           </a:p>
@@ -13354,8 +13793,8 @@
         </p:nvSpPr>
         <p:spPr>
           <a:xfrm>
-            <a:off x="5349240" y="1783080"/>
-            <a:ext cx="6522415" cy="4663440"/>
+            <a:off x="4069080" y="1783080"/>
+            <a:ext cx="7802575" cy="4663440"/>
           </a:xfrm>
           <a:prstGeom prst="rect">
             <a:avLst/>
@@ -13374,7 +13813,7 @@
               <a:buNone/>
             </a:pPr>
             <a:r>
-              <a:rPr lang="en-US" sz="4000" dirty="0">
+              <a:rPr lang="en-US" sz="4000" b="1" dirty="0">
                 <a:solidFill>
                   <a:srgbClr val="111111"/>
                 </a:solidFill>
@@ -13382,7 +13821,61 @@
                 <a:ea typeface="Times New Roman" pitchFamily="34" charset="-122"/>
                 <a:cs typeface="Times New Roman" pitchFamily="34" charset="-120"/>
               </a:rPr>
-              <a:t>Why is the inner core solid though it is very hot?</a:t>
+              <a:t>The mantle: </a:t>
+            </a:r>
+            <a:pPr algn="l" indent="0" marL="0">
+              <a:spcAft>
+                <a:spcPts val="800"/>
+              </a:spcAft>
+              <a:buNone/>
+            </a:pPr>
+            <a:r>
+              <a:rPr lang="en-US" sz="4000" dirty="0">
+                <a:solidFill>
+                  <a:srgbClr val="111111"/>
+                </a:solidFill>
+                <a:latin typeface="Times New Roman" pitchFamily="34" charset="0"/>
+                <a:ea typeface="Times New Roman" pitchFamily="34" charset="-122"/>
+                <a:cs typeface="Times New Roman" pitchFamily="34" charset="-120"/>
+              </a:rPr>
+              <a:t>It is about 2,900 km thick and made of very hot rock. Its upper part is partly molten and flows very slowly.</a:t>
+            </a:r>
+            <a:endParaRPr lang="en-US" sz="4000" dirty="0"/>
+          </a:p>
+          <a:p>
+            <a:pPr algn="l" indent="0" marL="0">
+              <a:spcAft>
+                <a:spcPts val="800"/>
+              </a:spcAft>
+              <a:buNone/>
+            </a:pPr>
+            <a:r>
+              <a:rPr lang="en-US" sz="4000" b="1" dirty="0">
+                <a:solidFill>
+                  <a:srgbClr val="111111"/>
+                </a:solidFill>
+                <a:latin typeface="Times New Roman" pitchFamily="34" charset="0"/>
+                <a:ea typeface="Times New Roman" pitchFamily="34" charset="-122"/>
+                <a:cs typeface="Times New Roman" pitchFamily="34" charset="-120"/>
+              </a:rPr>
+              <a:t>The outer core: </a:t>
+            </a:r>
+            <a:pPr algn="l" indent="0" marL="0">
+              <a:spcAft>
+                <a:spcPts val="800"/>
+              </a:spcAft>
+              <a:buNone/>
+            </a:pPr>
+            <a:r>
+              <a:rPr lang="en-US" sz="4000" dirty="0">
+                <a:solidFill>
+                  <a:srgbClr val="111111"/>
+                </a:solidFill>
+                <a:latin typeface="Times New Roman" pitchFamily="34" charset="0"/>
+                <a:ea typeface="Times New Roman" pitchFamily="34" charset="-122"/>
+                <a:cs typeface="Times New Roman" pitchFamily="34" charset="-120"/>
+              </a:rPr>
+              <a:t>It is about 2,200 km thick and made of liquid iron and nickel.</a:t>
             </a:r>
             <a:endParaRPr lang="en-US" sz="4000" dirty="0"/>
           </a:p>
@@ -13494,15 +13987,115 @@
                 <a:ea typeface="Calibri" pitchFamily="34" charset="-122"/>
                 <a:cs typeface="Calibri" pitchFamily="34" charset="-120"/>
               </a:rPr>
-              <a:t>FORMATIVE EVALUATION</a:t>
+              <a:t>BOARD SUMMARY</a:t>
             </a:r>
             <a:endParaRPr lang="en-US" sz="1400" dirty="0"/>
+          </a:p>
+        </p:txBody>
+      </p:sp>
+      <p:sp>
+        <p:nvSpPr>
+          <p:cNvPr id="3" name="Text 1"/>
+          <p:cNvSpPr/>
+          <p:nvPr/>
+        </p:nvSpPr>
+        <p:spPr>
+          <a:xfrm>
+            <a:off x="365760" y="1005840"/>
+            <a:ext cx="11460175" cy="731520"/>
+          </a:xfrm>
+          <a:prstGeom prst="rect">
+            <a:avLst/>
+          </a:prstGeom>
+          <a:noFill/>
+          <a:ln/>
+        </p:spPr>
+        <p:txBody>
+          <a:bodyPr wrap="square" lIns="0" tIns="0" rIns="0" bIns="0" rtlCol="0" anchor="ctr">
+            <a:normAutofit/>
+          </a:bodyPr>
+          <a:lstStyle/>
+          <a:p>
+            <a:pPr algn="ctr" indent="0" marL="0">
+              <a:buNone/>
+            </a:pPr>
+            <a:r>
+              <a:rPr lang="en-US" sz="3600" b="1" dirty="0">
+                <a:solidFill>
+                  <a:srgbClr val="990011"/>
+                </a:solidFill>
+                <a:latin typeface="Times New Roman" pitchFamily="34" charset="0"/>
+                <a:ea typeface="Times New Roman" pitchFamily="34" charset="-122"/>
+                <a:cs typeface="Times New Roman" pitchFamily="34" charset="-120"/>
+              </a:rPr>
+              <a:t>2. Brief Description of the Main Layers</a:t>
+            </a:r>
+            <a:endParaRPr lang="en-US" sz="3600" dirty="0"/>
+          </a:p>
+        </p:txBody>
+      </p:sp>
+      <p:sp>
+        <p:nvSpPr>
+          <p:cNvPr id="4" name="Text 2"/>
+          <p:cNvSpPr/>
+          <p:nvPr/>
+        </p:nvSpPr>
+        <p:spPr>
+          <a:xfrm>
+            <a:off x="365760" y="1783080"/>
+            <a:ext cx="4846320" cy="4617720"/>
+          </a:xfrm>
+          <a:prstGeom prst="rect">
+            <a:avLst/>
+          </a:prstGeom>
+          <a:noFill/>
+          <a:ln/>
+        </p:spPr>
+        <p:txBody>
+          <a:bodyPr wrap="square" lIns="0" tIns="0" rIns="0" bIns="0" rtlCol="0" anchor="t"/>
+          <a:lstStyle/>
+          <a:p>
+            <a:pPr algn="l" indent="0" marL="0">
+              <a:spcAft>
+                <a:spcPts val="800"/>
+              </a:spcAft>
+              <a:buNone/>
+            </a:pPr>
+            <a:r>
+              <a:rPr lang="en-US" sz="3600" b="1" dirty="0">
+                <a:solidFill>
+                  <a:srgbClr val="111111"/>
+                </a:solidFill>
+                <a:latin typeface="Times New Roman" pitchFamily="34" charset="0"/>
+                <a:ea typeface="Times New Roman" pitchFamily="34" charset="-122"/>
+                <a:cs typeface="Times New Roman" pitchFamily="34" charset="-120"/>
+              </a:rPr>
+              <a:t>The inner core: </a:t>
+            </a:r>
+            <a:pPr algn="l" indent="0" marL="0">
+              <a:spcAft>
+                <a:spcPts val="800"/>
+              </a:spcAft>
+              <a:buNone/>
+            </a:pPr>
+            <a:r>
+              <a:rPr lang="en-US" sz="3600" dirty="0">
+                <a:solidFill>
+                  <a:srgbClr val="111111"/>
+                </a:solidFill>
+                <a:latin typeface="Times New Roman" pitchFamily="34" charset="0"/>
+                <a:ea typeface="Times New Roman" pitchFamily="34" charset="-122"/>
+                <a:cs typeface="Times New Roman" pitchFamily="34" charset="-120"/>
+              </a:rPr>
+              <a:t>It is a solid ball of iron and nickel with a radius of about 1,220 km. Its temperature is about 5,000 to 6,000 °C.</a:t>
+            </a:r>
+            <a:endParaRPr lang="en-US" sz="3600" dirty="0"/>
           </a:p>
         </p:txBody>
       </p:sp>
       <p:pic>
         <p:nvPicPr>
-          <p:cNvPr id="3" name="Image 0" descr="/home/claude/f4/img/minesec_sheet.png">    </p:cNvPr>
+          <p:cNvPr id="5" name="Image 0" descr="/home/claude/f4/img/v2/earth_depth_last.png">    </p:cNvPr>
           <p:cNvPicPr>
             <a:picLocks noChangeAspect="1"/>
           </p:cNvPicPr>
@@ -13516,8 +14109,8 @@
         </p:blipFill>
         <p:spPr>
           <a:xfrm>
-            <a:off x="0" y="658368"/>
-            <a:ext cx="5120640" cy="5833872"/>
+            <a:off x="5349240" y="2617506"/>
+            <a:ext cx="6659575" cy="2601397"/>
           </a:xfrm>
           <a:prstGeom prst="rect">
             <a:avLst/>
@@ -13526,14 +14119,14 @@
       </p:pic>
       <p:sp>
         <p:nvSpPr>
-          <p:cNvPr id="4" name="Text 1"/>
+          <p:cNvPr id="6" name="Text 3"/>
           <p:cNvSpPr/>
           <p:nvPr/>
         </p:nvSpPr>
         <p:spPr>
           <a:xfrm>
-            <a:off x="5349240" y="1005840"/>
-            <a:ext cx="6522415" cy="731520"/>
+            <a:off x="5349240" y="6089904"/>
+            <a:ext cx="6659575" cy="347472"/>
           </a:xfrm>
           <a:prstGeom prst="rect">
             <a:avLst/>
@@ -13542,68 +14135,24 @@
           <a:ln/>
         </p:spPr>
         <p:txBody>
-          <a:bodyPr wrap="square" lIns="0" tIns="0" rIns="0" bIns="0" rtlCol="0" anchor="ctr">
-            <a:normAutofit/>
-          </a:bodyPr>
+          <a:bodyPr wrap="square" lIns="0" tIns="0" rIns="0" bIns="0" rtlCol="0" anchor="ctr"/>
           <a:lstStyle/>
           <a:p>
             <a:pPr algn="ctr" indent="0" marL="0">
               <a:buNone/>
             </a:pPr>
             <a:r>
-              <a:rPr lang="en-US" sz="3600" b="1" dirty="0">
-                <a:solidFill>
-                  <a:srgbClr val="990011"/>
+              <a:rPr lang="en-US" sz="1600" i="1" dirty="0">
+                <a:solidFill>
+                  <a:srgbClr val="555555"/>
                 </a:solidFill>
                 <a:latin typeface="Times New Roman" pitchFamily="34" charset="0"/>
                 <a:ea typeface="Times New Roman" pitchFamily="34" charset="-122"/>
                 <a:cs typeface="Times New Roman" pitchFamily="34" charset="-120"/>
               </a:rPr>
-              <a:t>Expected Answer</a:t>
-            </a:r>
-            <a:endParaRPr lang="en-US" sz="3600" dirty="0"/>
-          </a:p>
-        </p:txBody>
-      </p:sp>
-      <p:sp>
-        <p:nvSpPr>
-          <p:cNvPr id="5" name="Text 2"/>
-          <p:cNvSpPr/>
-          <p:nvPr/>
-        </p:nvSpPr>
-        <p:spPr>
-          <a:xfrm>
-            <a:off x="5349240" y="1783080"/>
-            <a:ext cx="6522415" cy="4663440"/>
-          </a:xfrm>
-          <a:prstGeom prst="rect">
-            <a:avLst/>
-          </a:prstGeom>
-          <a:noFill/>
-          <a:ln/>
-        </p:spPr>
-        <p:txBody>
-          <a:bodyPr wrap="square" lIns="0" tIns="0" rIns="0" bIns="0" rtlCol="0" anchor="t"/>
-          <a:lstStyle/>
-          <a:p>
-            <a:pPr algn="l" indent="0" marL="0">
-              <a:spcAft>
-                <a:spcPts val="800"/>
-              </a:spcAft>
-              <a:buNone/>
-            </a:pPr>
-            <a:r>
-              <a:rPr lang="en-US" sz="4000" dirty="0">
-                <a:solidFill>
-                  <a:srgbClr val="111111"/>
-                </a:solidFill>
-                <a:latin typeface="Times New Roman" pitchFamily="34" charset="0"/>
-                <a:ea typeface="Times New Roman" pitchFamily="34" charset="-122"/>
-                <a:cs typeface="Times New Roman" pitchFamily="34" charset="-120"/>
-              </a:rPr>
-              <a:t>Because of the enormous pressure.</a:t>
-            </a:r>
-            <a:endParaRPr lang="en-US" sz="4000" dirty="0"/>
+              <a:t>Illustration: the centre of the Earth</a:t>
+            </a:r>
+            <a:endParaRPr lang="en-US" sz="1600" dirty="0"/>
           </a:p>
         </p:txBody>
       </p:sp>
@@ -13713,7 +14262,7 @@
                 <a:ea typeface="Calibri" pitchFamily="34" charset="-122"/>
                 <a:cs typeface="Calibri" pitchFamily="34" charset="-120"/>
               </a:rPr>
-              <a:t>REMEDIATION</a:t>
+              <a:t>FORMATIVE EVALUATION</a:t>
             </a:r>
             <a:endParaRPr lang="en-US" sz="1400" dirty="0"/>
           </a:p>
@@ -13736,7 +14285,7 @@
         <p:spPr>
           <a:xfrm>
             <a:off x="0" y="658368"/>
-            <a:ext cx="2468880" cy="5833872"/>
+            <a:ext cx="5120640" cy="5833872"/>
           </a:xfrm>
           <a:prstGeom prst="rect">
             <a:avLst/>
@@ -13751,8 +14300,8 @@
         </p:nvSpPr>
         <p:spPr>
           <a:xfrm>
-            <a:off x="2697480" y="1005840"/>
-            <a:ext cx="9174175" cy="731520"/>
+            <a:off x="5349240" y="1005840"/>
+            <a:ext cx="6522415" cy="731520"/>
           </a:xfrm>
           <a:prstGeom prst="rect">
             <a:avLst/>
@@ -13778,7 +14327,7 @@
                 <a:ea typeface="Times New Roman" pitchFamily="34" charset="-122"/>
                 <a:cs typeface="Times New Roman" pitchFamily="34" charset="-120"/>
               </a:rPr>
-              <a:t>Remediation</a:t>
+              <a:t>Evaluation 1</a:t>
             </a:r>
             <a:endParaRPr lang="en-US" sz="3600" dirty="0"/>
           </a:p>
@@ -13792,8 +14341,8 @@
         </p:nvSpPr>
         <p:spPr>
           <a:xfrm>
-            <a:off x="2697480" y="1783080"/>
-            <a:ext cx="9174175" cy="4663440"/>
+            <a:off x="5349240" y="1783080"/>
+            <a:ext cx="6522415" cy="4663440"/>
           </a:xfrm>
           <a:prstGeom prst="rect">
             <a:avLst/>
@@ -13812,7 +14361,7 @@
               <a:buNone/>
             </a:pPr>
             <a:r>
-              <a:rPr lang="en-US" sz="4000" b="1" dirty="0">
+              <a:rPr lang="en-US" sz="4000" dirty="0">
                 <a:solidFill>
                   <a:srgbClr val="111111"/>
                 </a:solidFill>
@@ -13820,73 +14369,7 @@
                 <a:ea typeface="Times New Roman" pitchFamily="34" charset="-122"/>
                 <a:cs typeface="Times New Roman" pitchFamily="34" charset="-120"/>
               </a:rPr>
-              <a:t>Fill in the blanks:</a:t>
-            </a:r>
-            <a:endParaRPr lang="en-US" sz="4000" dirty="0"/>
-          </a:p>
-          <a:p>
-            <a:pPr algn="l" marL="342900" indent="-342900">
-              <a:spcAft>
-                <a:spcPts val="800"/>
-              </a:spcAft>
-              <a:buSzPct val="100000"/>
-              <a:buFont typeface="+mj-lt"/>
-              <a:buAutoNum type="arabicPeriod" startAt="1"/>
-            </a:pPr>
-            <a:r>
-              <a:rPr lang="en-US" sz="4000" dirty="0">
-                <a:solidFill>
-                  <a:srgbClr val="111111"/>
-                </a:solidFill>
-                <a:latin typeface="Times New Roman" pitchFamily="34" charset="0"/>
-                <a:ea typeface="Times New Roman" pitchFamily="34" charset="-122"/>
-                <a:cs typeface="Times New Roman" pitchFamily="34" charset="-120"/>
-              </a:rPr>
-              <a:t>The thin outer layer of the Earth is the ______.</a:t>
-            </a:r>
-            <a:endParaRPr lang="en-US" sz="4000" dirty="0"/>
-          </a:p>
-          <a:p>
-            <a:pPr algn="l" marL="342900" indent="-342900">
-              <a:spcAft>
-                <a:spcPts val="800"/>
-              </a:spcAft>
-              <a:buSzPct val="100000"/>
-              <a:buFont typeface="+mj-lt"/>
-              <a:buAutoNum type="arabicPeriod" startAt="1"/>
-            </a:pPr>
-            <a:r>
-              <a:rPr lang="en-US" sz="4000" dirty="0">
-                <a:solidFill>
-                  <a:srgbClr val="111111"/>
-                </a:solidFill>
-                <a:latin typeface="Times New Roman" pitchFamily="34" charset="0"/>
-                <a:ea typeface="Times New Roman" pitchFamily="34" charset="-122"/>
-                <a:cs typeface="Times New Roman" pitchFamily="34" charset="-120"/>
-              </a:rPr>
-              <a:t>The layer under the crust is the ______.</a:t>
-            </a:r>
-            <a:endParaRPr lang="en-US" sz="4000" dirty="0"/>
-          </a:p>
-          <a:p>
-            <a:pPr algn="l" marL="342900" indent="-342900">
-              <a:spcAft>
-                <a:spcPts val="800"/>
-              </a:spcAft>
-              <a:buSzPct val="100000"/>
-              <a:buFont typeface="+mj-lt"/>
-              <a:buAutoNum type="arabicPeriod" startAt="1"/>
-            </a:pPr>
-            <a:r>
-              <a:rPr lang="en-US" sz="4000" dirty="0">
-                <a:solidFill>
-                  <a:srgbClr val="111111"/>
-                </a:solidFill>
-                <a:latin typeface="Times New Roman" pitchFamily="34" charset="0"/>
-                <a:ea typeface="Times New Roman" pitchFamily="34" charset="-122"/>
-                <a:cs typeface="Times New Roman" pitchFamily="34" charset="-120"/>
-              </a:rPr>
-              <a:t>The outer core is made of ______ iron.</a:t>
+              <a:t>Name the layer on which we live.</a:t>
             </a:r>
             <a:endParaRPr lang="en-US" sz="4000" dirty="0"/>
           </a:p>
@@ -13998,7 +14481,7 @@
                 <a:ea typeface="Calibri" pitchFamily="34" charset="-122"/>
                 <a:cs typeface="Calibri" pitchFamily="34" charset="-120"/>
               </a:rPr>
-              <a:t>HOMEWORK</a:t>
+              <a:t>FORMATIVE EVALUATION</a:t>
             </a:r>
             <a:endParaRPr lang="en-US" sz="1400" dirty="0"/>
           </a:p>
@@ -14063,7 +14546,7 @@
                 <a:ea typeface="Times New Roman" pitchFamily="34" charset="-122"/>
                 <a:cs typeface="Times New Roman" pitchFamily="34" charset="-120"/>
               </a:rPr>
-              <a:t>Homework</a:t>
+              <a:t>Expected Answer</a:t>
             </a:r>
             <a:endParaRPr lang="en-US" sz="3600" dirty="0"/>
           </a:p>
@@ -14105,7 +14588,7 @@
                 <a:ea typeface="Times New Roman" pitchFamily="34" charset="-122"/>
                 <a:cs typeface="Times New Roman" pitchFamily="34" charset="-120"/>
               </a:rPr>
-              <a:t>Collect three different stones or building materials (for example a piece of granite, a sandstone block and a piece of marble or tile). Write where you found each one.</a:t>
+              <a:t>The crust.</a:t>
             </a:r>
             <a:endParaRPr lang="en-US" sz="4000" dirty="0"/>
           </a:p>
@@ -14456,7 +14939,7 @@
                 <a:ea typeface="Calibri" pitchFamily="34" charset="-122"/>
                 <a:cs typeface="Calibri" pitchFamily="34" charset="-120"/>
               </a:rPr>
-              <a:t>NEXT LESSON</a:t>
+              <a:t>FORMATIVE EVALUATION</a:t>
             </a:r>
             <a:endParaRPr lang="en-US" sz="1400" dirty="0"/>
           </a:p>
@@ -14521,7 +15004,7 @@
                 <a:ea typeface="Times New Roman" pitchFamily="34" charset="-122"/>
                 <a:cs typeface="Times New Roman" pitchFamily="34" charset="-120"/>
               </a:rPr>
-              <a:t>Next Lesson</a:t>
+              <a:t>Evaluation 2</a:t>
             </a:r>
             <a:endParaRPr lang="en-US" sz="3600" dirty="0"/>
           </a:p>
@@ -14545,17 +15028,17 @@
           <a:ln/>
         </p:spPr>
         <p:txBody>
-          <a:bodyPr wrap="square" lIns="0" tIns="0" rIns="0" bIns="0" rtlCol="0" anchor="ctr"/>
-          <a:lstStyle/>
-          <a:p>
-            <a:pPr algn="ctr" indent="0" marL="0">
+          <a:bodyPr wrap="square" lIns="0" tIns="0" rIns="0" bIns="0" rtlCol="0" anchor="t"/>
+          <a:lstStyle/>
+          <a:p>
+            <a:pPr algn="l" indent="0" marL="0">
               <a:spcAft>
                 <a:spcPts val="800"/>
               </a:spcAft>
               <a:buNone/>
             </a:pPr>
             <a:r>
-              <a:rPr lang="en-US" sz="4000" b="1" dirty="0">
+              <a:rPr lang="en-US" sz="4000" dirty="0">
                 <a:solidFill>
                   <a:srgbClr val="111111"/>
                 </a:solidFill>
@@ -14563,27 +15046,7 @@
                 <a:ea typeface="Times New Roman" pitchFamily="34" charset="-122"/>
                 <a:cs typeface="Times New Roman" pitchFamily="34" charset="-120"/>
               </a:rPr>
-              <a:t>Our next lesson will be on:</a:t>
-            </a:r>
-            <a:endParaRPr lang="en-US" sz="4000" dirty="0"/>
-          </a:p>
-          <a:p>
-            <a:pPr algn="ctr" indent="0" marL="0">
-              <a:spcAft>
-                <a:spcPts val="800"/>
-              </a:spcAft>
-              <a:buNone/>
-            </a:pPr>
-            <a:r>
-              <a:rPr lang="en-US" sz="4000" b="1" dirty="0">
-                <a:solidFill>
-                  <a:srgbClr val="990011"/>
-                </a:solidFill>
-                <a:latin typeface="Times New Roman" pitchFamily="34" charset="0"/>
-                <a:ea typeface="Times New Roman" pitchFamily="34" charset="-122"/>
-                <a:cs typeface="Times New Roman" pitchFamily="34" charset="-120"/>
-              </a:rPr>
-              <a:t>Lesson 8: Rocks</a:t>
+              <a:t>Why is the inner core solid though it is very hot?</a:t>
             </a:r>
             <a:endParaRPr lang="en-US" sz="4000" dirty="0"/>
           </a:p>
@@ -14695,6 +15158,968 @@
                 <a:ea typeface="Calibri" pitchFamily="34" charset="-122"/>
                 <a:cs typeface="Calibri" pitchFamily="34" charset="-120"/>
               </a:rPr>
+              <a:t>FORMATIVE EVALUATION</a:t>
+            </a:r>
+            <a:endParaRPr lang="en-US" sz="1400" dirty="0"/>
+          </a:p>
+        </p:txBody>
+      </p:sp>
+      <p:pic>
+        <p:nvPicPr>
+          <p:cNvPr id="3" name="Image 0" descr="/home/claude/f4/img/minesec_sheet.png">    </p:cNvPr>
+          <p:cNvPicPr>
+            <a:picLocks noChangeAspect="1"/>
+          </p:cNvPicPr>
+          <p:nvPr/>
+        </p:nvPicPr>
+        <p:blipFill>
+          <a:blip r:embed="rId1"/>
+          <a:stretch>
+            <a:fillRect/>
+          </a:stretch>
+        </p:blipFill>
+        <p:spPr>
+          <a:xfrm>
+            <a:off x="0" y="658368"/>
+            <a:ext cx="5120640" cy="5833872"/>
+          </a:xfrm>
+          <a:prstGeom prst="rect">
+            <a:avLst/>
+          </a:prstGeom>
+        </p:spPr>
+      </p:pic>
+      <p:sp>
+        <p:nvSpPr>
+          <p:cNvPr id="4" name="Text 1"/>
+          <p:cNvSpPr/>
+          <p:nvPr/>
+        </p:nvSpPr>
+        <p:spPr>
+          <a:xfrm>
+            <a:off x="5349240" y="1005840"/>
+            <a:ext cx="6522415" cy="731520"/>
+          </a:xfrm>
+          <a:prstGeom prst="rect">
+            <a:avLst/>
+          </a:prstGeom>
+          <a:noFill/>
+          <a:ln/>
+        </p:spPr>
+        <p:txBody>
+          <a:bodyPr wrap="square" lIns="0" tIns="0" rIns="0" bIns="0" rtlCol="0" anchor="ctr">
+            <a:normAutofit/>
+          </a:bodyPr>
+          <a:lstStyle/>
+          <a:p>
+            <a:pPr algn="ctr" indent="0" marL="0">
+              <a:buNone/>
+            </a:pPr>
+            <a:r>
+              <a:rPr lang="en-US" sz="3600" b="1" dirty="0">
+                <a:solidFill>
+                  <a:srgbClr val="990011"/>
+                </a:solidFill>
+                <a:latin typeface="Times New Roman" pitchFamily="34" charset="0"/>
+                <a:ea typeface="Times New Roman" pitchFamily="34" charset="-122"/>
+                <a:cs typeface="Times New Roman" pitchFamily="34" charset="-120"/>
+              </a:rPr>
+              <a:t>Expected Answer</a:t>
+            </a:r>
+            <a:endParaRPr lang="en-US" sz="3600" dirty="0"/>
+          </a:p>
+        </p:txBody>
+      </p:sp>
+      <p:sp>
+        <p:nvSpPr>
+          <p:cNvPr id="5" name="Text 2"/>
+          <p:cNvSpPr/>
+          <p:nvPr/>
+        </p:nvSpPr>
+        <p:spPr>
+          <a:xfrm>
+            <a:off x="5349240" y="1783080"/>
+            <a:ext cx="6522415" cy="4663440"/>
+          </a:xfrm>
+          <a:prstGeom prst="rect">
+            <a:avLst/>
+          </a:prstGeom>
+          <a:noFill/>
+          <a:ln/>
+        </p:spPr>
+        <p:txBody>
+          <a:bodyPr wrap="square" lIns="0" tIns="0" rIns="0" bIns="0" rtlCol="0" anchor="t"/>
+          <a:lstStyle/>
+          <a:p>
+            <a:pPr algn="l" indent="0" marL="0">
+              <a:spcAft>
+                <a:spcPts val="800"/>
+              </a:spcAft>
+              <a:buNone/>
+            </a:pPr>
+            <a:r>
+              <a:rPr lang="en-US" sz="4000" dirty="0">
+                <a:solidFill>
+                  <a:srgbClr val="111111"/>
+                </a:solidFill>
+                <a:latin typeface="Times New Roman" pitchFamily="34" charset="0"/>
+                <a:ea typeface="Times New Roman" pitchFamily="34" charset="-122"/>
+                <a:cs typeface="Times New Roman" pitchFamily="34" charset="-120"/>
+              </a:rPr>
+              <a:t>Because of the enormous pressure.</a:t>
+            </a:r>
+            <a:endParaRPr lang="en-US" sz="4000" dirty="0"/>
+          </a:p>
+        </p:txBody>
+      </p:sp>
+      <p:sp>
+        <p:nvSpPr>
+          <p:cNvPr id="25" name="Slide Number Placeholder 0"/>
+          <p:cNvSpPr>
+            <a:spLocks noGrp="1"/>
+          </p:cNvSpPr>
+          <p:nvPr>
+            <p:ph type="sldNum" sz="quarter" idx="4294967295"/>
+          </p:nvPr>
+        </p:nvSpPr>
+        <p:spPr>
+          <a:xfrm>
+            <a:off x="27432" y="91440"/>
+            <a:ext cx="585216" cy="475488"/>
+          </a:xfrm>
+          <a:prstGeom prst="rect">
+            <a:avLst/>
+          </a:prstGeom>
+          <a:extLst>
+            <a:ext uri="{C572A759-6A51-4108-AA02-DFA0A04FC94B}">
+              <ma14:wrappingTextBoxFlag xmlns:ma14="http://schemas.microsoft.com/office/mac/drawingml/2011/main" val="0"/>
+            </a:ext>
+          </a:extLst>
+        </p:spPr>
+        <p:txBody>
+          <a:bodyPr/>
+          <a:lstStyle>
+            <a:lvl1pPr>
+              <a:defRPr sz="2000">
+                <a:solidFill>
+                  <a:srgbClr val="FFFFFF"/>
+                </a:solidFill>
+                <a:latin typeface="Calibri"/>
+                <a:ea typeface="Calibri"/>
+                <a:cs typeface="Calibri"/>
+              </a:defRPr>
+            </a:lvl1pPr>
+          </a:lstStyle>
+          <a:p>
+            <a:pPr algn="ctr"/>
+            <a:fld id="{F7021451-1387-4CA6-816F-3879F97B5CBC}" type="slidenum">
+              <a:rPr b="1" lang="en-US"/>
+              <a:t>41</a:t>
+            </a:fld>
+            <a:endParaRPr lang="en-US"/>
+          </a:p>
+        </p:txBody>
+      </p:sp>
+    </p:spTree>
+  </p:cSld>
+  <p:clrMapOvr>
+    <a:masterClrMapping/>
+  </p:clrMapOvr>
+</p:sld>
+</file>
+
+<file path=ppt/slides/slide42.xml><?xml version="1.0" encoding="utf-8"?>
+<p:sld xmlns:a="http://schemas.openxmlformats.org/drawingml/2006/main" xmlns:r="http://schemas.openxmlformats.org/officeDocument/2006/relationships" xmlns:p="http://schemas.openxmlformats.org/presentationml/2006/main">
+  <p:cSld name="Slide 42">
+    <p:spTree>
+      <p:nvGrpSpPr>
+        <p:cNvPr id="1" name=""/>
+        <p:cNvGrpSpPr/>
+        <p:nvPr/>
+      </p:nvGrpSpPr>
+      <p:grpSpPr>
+        <a:xfrm>
+          <a:off x="0" y="0"/>
+          <a:ext cx="0" cy="0"/>
+          <a:chOff x="0" y="0"/>
+          <a:chExt cx="0" cy="0"/>
+        </a:xfrm>
+      </p:grpSpPr>
+      <p:sp>
+        <p:nvSpPr>
+          <p:cNvPr id="2" name="Text 0"/>
+          <p:cNvSpPr/>
+          <p:nvPr/>
+        </p:nvSpPr>
+        <p:spPr>
+          <a:xfrm>
+            <a:off x="457200" y="713232"/>
+            <a:ext cx="11368735" cy="274320"/>
+          </a:xfrm>
+          <a:prstGeom prst="rect">
+            <a:avLst/>
+          </a:prstGeom>
+          <a:noFill/>
+          <a:ln/>
+        </p:spPr>
+        <p:txBody>
+          <a:bodyPr wrap="square" lIns="0" tIns="0" rIns="0" bIns="0" rtlCol="0" anchor="ctr"/>
+          <a:lstStyle/>
+          <a:p>
+            <a:pPr algn="r" indent="0" marL="0">
+              <a:buNone/>
+            </a:pPr>
+            <a:r>
+              <a:rPr lang="en-US" sz="1400" b="1" dirty="0">
+                <a:solidFill>
+                  <a:srgbClr val="1C3F6E"/>
+                </a:solidFill>
+                <a:latin typeface="Calibri" pitchFamily="34" charset="0"/>
+                <a:ea typeface="Calibri" pitchFamily="34" charset="-122"/>
+                <a:cs typeface="Calibri" pitchFamily="34" charset="-120"/>
+              </a:rPr>
+              <a:t>REMEDIATION</a:t>
+            </a:r>
+            <a:endParaRPr lang="en-US" sz="1400" dirty="0"/>
+          </a:p>
+        </p:txBody>
+      </p:sp>
+      <p:pic>
+        <p:nvPicPr>
+          <p:cNvPr id="3" name="Image 0" descr="/home/claude/f4/img/minesec_sheet.png">    </p:cNvPr>
+          <p:cNvPicPr>
+            <a:picLocks noChangeAspect="1"/>
+          </p:cNvPicPr>
+          <p:nvPr/>
+        </p:nvPicPr>
+        <p:blipFill>
+          <a:blip r:embed="rId1"/>
+          <a:stretch>
+            <a:fillRect/>
+          </a:stretch>
+        </p:blipFill>
+        <p:spPr>
+          <a:xfrm>
+            <a:off x="0" y="658368"/>
+            <a:ext cx="2468880" cy="5833872"/>
+          </a:xfrm>
+          <a:prstGeom prst="rect">
+            <a:avLst/>
+          </a:prstGeom>
+        </p:spPr>
+      </p:pic>
+      <p:sp>
+        <p:nvSpPr>
+          <p:cNvPr id="4" name="Text 1"/>
+          <p:cNvSpPr/>
+          <p:nvPr/>
+        </p:nvSpPr>
+        <p:spPr>
+          <a:xfrm>
+            <a:off x="2697480" y="1005840"/>
+            <a:ext cx="9174175" cy="731520"/>
+          </a:xfrm>
+          <a:prstGeom prst="rect">
+            <a:avLst/>
+          </a:prstGeom>
+          <a:noFill/>
+          <a:ln/>
+        </p:spPr>
+        <p:txBody>
+          <a:bodyPr wrap="square" lIns="0" tIns="0" rIns="0" bIns="0" rtlCol="0" anchor="ctr">
+            <a:normAutofit/>
+          </a:bodyPr>
+          <a:lstStyle/>
+          <a:p>
+            <a:pPr algn="ctr" indent="0" marL="0">
+              <a:buNone/>
+            </a:pPr>
+            <a:r>
+              <a:rPr lang="en-US" sz="3600" b="1" dirty="0">
+                <a:solidFill>
+                  <a:srgbClr val="990011"/>
+                </a:solidFill>
+                <a:latin typeface="Times New Roman" pitchFamily="34" charset="0"/>
+                <a:ea typeface="Times New Roman" pitchFamily="34" charset="-122"/>
+                <a:cs typeface="Times New Roman" pitchFamily="34" charset="-120"/>
+              </a:rPr>
+              <a:t>Remediation</a:t>
+            </a:r>
+            <a:endParaRPr lang="en-US" sz="3600" dirty="0"/>
+          </a:p>
+        </p:txBody>
+      </p:sp>
+      <p:sp>
+        <p:nvSpPr>
+          <p:cNvPr id="5" name="Text 2"/>
+          <p:cNvSpPr/>
+          <p:nvPr/>
+        </p:nvSpPr>
+        <p:spPr>
+          <a:xfrm>
+            <a:off x="2697480" y="1783080"/>
+            <a:ext cx="9174175" cy="4663440"/>
+          </a:xfrm>
+          <a:prstGeom prst="rect">
+            <a:avLst/>
+          </a:prstGeom>
+          <a:noFill/>
+          <a:ln/>
+        </p:spPr>
+        <p:txBody>
+          <a:bodyPr wrap="square" lIns="0" tIns="0" rIns="0" bIns="0" rtlCol="0" anchor="t"/>
+          <a:lstStyle/>
+          <a:p>
+            <a:pPr algn="l" indent="0" marL="0">
+              <a:spcAft>
+                <a:spcPts val="800"/>
+              </a:spcAft>
+              <a:buNone/>
+            </a:pPr>
+            <a:r>
+              <a:rPr lang="en-US" sz="4000" b="1" dirty="0">
+                <a:solidFill>
+                  <a:srgbClr val="111111"/>
+                </a:solidFill>
+                <a:latin typeface="Times New Roman" pitchFamily="34" charset="0"/>
+                <a:ea typeface="Times New Roman" pitchFamily="34" charset="-122"/>
+                <a:cs typeface="Times New Roman" pitchFamily="34" charset="-120"/>
+              </a:rPr>
+              <a:t>Fill in the blanks:</a:t>
+            </a:r>
+            <a:endParaRPr lang="en-US" sz="4000" dirty="0"/>
+          </a:p>
+          <a:p>
+            <a:pPr algn="l" marL="342900" indent="-342900">
+              <a:spcAft>
+                <a:spcPts val="800"/>
+              </a:spcAft>
+              <a:buSzPct val="100000"/>
+              <a:buFont typeface="+mj-lt"/>
+              <a:buAutoNum type="arabicPeriod" startAt="1"/>
+            </a:pPr>
+            <a:r>
+              <a:rPr lang="en-US" sz="4000" dirty="0">
+                <a:solidFill>
+                  <a:srgbClr val="111111"/>
+                </a:solidFill>
+                <a:latin typeface="Times New Roman" pitchFamily="34" charset="0"/>
+                <a:ea typeface="Times New Roman" pitchFamily="34" charset="-122"/>
+                <a:cs typeface="Times New Roman" pitchFamily="34" charset="-120"/>
+              </a:rPr>
+              <a:t>The thin outer layer of the Earth is the ______.</a:t>
+            </a:r>
+            <a:endParaRPr lang="en-US" sz="4000" dirty="0"/>
+          </a:p>
+          <a:p>
+            <a:pPr algn="l" marL="342900" indent="-342900">
+              <a:spcAft>
+                <a:spcPts val="800"/>
+              </a:spcAft>
+              <a:buSzPct val="100000"/>
+              <a:buFont typeface="+mj-lt"/>
+              <a:buAutoNum type="arabicPeriod" startAt="1"/>
+            </a:pPr>
+            <a:r>
+              <a:rPr lang="en-US" sz="4000" dirty="0">
+                <a:solidFill>
+                  <a:srgbClr val="111111"/>
+                </a:solidFill>
+                <a:latin typeface="Times New Roman" pitchFamily="34" charset="0"/>
+                <a:ea typeface="Times New Roman" pitchFamily="34" charset="-122"/>
+                <a:cs typeface="Times New Roman" pitchFamily="34" charset="-120"/>
+              </a:rPr>
+              <a:t>The layer under the crust is the ______.</a:t>
+            </a:r>
+            <a:endParaRPr lang="en-US" sz="4000" dirty="0"/>
+          </a:p>
+          <a:p>
+            <a:pPr algn="l" marL="342900" indent="-342900">
+              <a:spcAft>
+                <a:spcPts val="800"/>
+              </a:spcAft>
+              <a:buSzPct val="100000"/>
+              <a:buFont typeface="+mj-lt"/>
+              <a:buAutoNum type="arabicPeriod" startAt="1"/>
+            </a:pPr>
+            <a:r>
+              <a:rPr lang="en-US" sz="4000" dirty="0">
+                <a:solidFill>
+                  <a:srgbClr val="111111"/>
+                </a:solidFill>
+                <a:latin typeface="Times New Roman" pitchFamily="34" charset="0"/>
+                <a:ea typeface="Times New Roman" pitchFamily="34" charset="-122"/>
+                <a:cs typeface="Times New Roman" pitchFamily="34" charset="-120"/>
+              </a:rPr>
+              <a:t>The outer core is made of ______ iron.</a:t>
+            </a:r>
+            <a:endParaRPr lang="en-US" sz="4000" dirty="0"/>
+          </a:p>
+        </p:txBody>
+      </p:sp>
+      <p:sp>
+        <p:nvSpPr>
+          <p:cNvPr id="25" name="Slide Number Placeholder 0"/>
+          <p:cNvSpPr>
+            <a:spLocks noGrp="1"/>
+          </p:cNvSpPr>
+          <p:nvPr>
+            <p:ph type="sldNum" sz="quarter" idx="4294967295"/>
+          </p:nvPr>
+        </p:nvSpPr>
+        <p:spPr>
+          <a:xfrm>
+            <a:off x="27432" y="91440"/>
+            <a:ext cx="585216" cy="475488"/>
+          </a:xfrm>
+          <a:prstGeom prst="rect">
+            <a:avLst/>
+          </a:prstGeom>
+          <a:extLst>
+            <a:ext uri="{C572A759-6A51-4108-AA02-DFA0A04FC94B}">
+              <ma14:wrappingTextBoxFlag xmlns:ma14="http://schemas.microsoft.com/office/mac/drawingml/2011/main" val="0"/>
+            </a:ext>
+          </a:extLst>
+        </p:spPr>
+        <p:txBody>
+          <a:bodyPr/>
+          <a:lstStyle>
+            <a:lvl1pPr>
+              <a:defRPr sz="2000">
+                <a:solidFill>
+                  <a:srgbClr val="FFFFFF"/>
+                </a:solidFill>
+                <a:latin typeface="Calibri"/>
+                <a:ea typeface="Calibri"/>
+                <a:cs typeface="Calibri"/>
+              </a:defRPr>
+            </a:lvl1pPr>
+          </a:lstStyle>
+          <a:p>
+            <a:pPr algn="ctr"/>
+            <a:fld id="{F7021451-1387-4CA6-816F-3879F97B5CBC}" type="slidenum">
+              <a:rPr b="1" lang="en-US"/>
+              <a:t>42</a:t>
+            </a:fld>
+            <a:endParaRPr lang="en-US"/>
+          </a:p>
+        </p:txBody>
+      </p:sp>
+    </p:spTree>
+  </p:cSld>
+  <p:clrMapOvr>
+    <a:masterClrMapping/>
+  </p:clrMapOvr>
+</p:sld>
+</file>
+
+<file path=ppt/slides/slide43.xml><?xml version="1.0" encoding="utf-8"?>
+<p:sld xmlns:a="http://schemas.openxmlformats.org/drawingml/2006/main" xmlns:r="http://schemas.openxmlformats.org/officeDocument/2006/relationships" xmlns:p="http://schemas.openxmlformats.org/presentationml/2006/main">
+  <p:cSld name="Slide 43">
+    <p:spTree>
+      <p:nvGrpSpPr>
+        <p:cNvPr id="1" name=""/>
+        <p:cNvGrpSpPr/>
+        <p:nvPr/>
+      </p:nvGrpSpPr>
+      <p:grpSpPr>
+        <a:xfrm>
+          <a:off x="0" y="0"/>
+          <a:ext cx="0" cy="0"/>
+          <a:chOff x="0" y="0"/>
+          <a:chExt cx="0" cy="0"/>
+        </a:xfrm>
+      </p:grpSpPr>
+      <p:sp>
+        <p:nvSpPr>
+          <p:cNvPr id="2" name="Text 0"/>
+          <p:cNvSpPr/>
+          <p:nvPr/>
+        </p:nvSpPr>
+        <p:spPr>
+          <a:xfrm>
+            <a:off x="457200" y="713232"/>
+            <a:ext cx="11368735" cy="274320"/>
+          </a:xfrm>
+          <a:prstGeom prst="rect">
+            <a:avLst/>
+          </a:prstGeom>
+          <a:noFill/>
+          <a:ln/>
+        </p:spPr>
+        <p:txBody>
+          <a:bodyPr wrap="square" lIns="0" tIns="0" rIns="0" bIns="0" rtlCol="0" anchor="ctr"/>
+          <a:lstStyle/>
+          <a:p>
+            <a:pPr algn="r" indent="0" marL="0">
+              <a:buNone/>
+            </a:pPr>
+            <a:r>
+              <a:rPr lang="en-US" sz="1400" b="1" dirty="0">
+                <a:solidFill>
+                  <a:srgbClr val="1C3F6E"/>
+                </a:solidFill>
+                <a:latin typeface="Calibri" pitchFamily="34" charset="0"/>
+                <a:ea typeface="Calibri" pitchFamily="34" charset="-122"/>
+                <a:cs typeface="Calibri" pitchFamily="34" charset="-120"/>
+              </a:rPr>
+              <a:t>HOMEWORK</a:t>
+            </a:r>
+            <a:endParaRPr lang="en-US" sz="1400" dirty="0"/>
+          </a:p>
+        </p:txBody>
+      </p:sp>
+      <p:pic>
+        <p:nvPicPr>
+          <p:cNvPr id="3" name="Image 0" descr="/home/claude/f4/img/minesec_sheet.png">    </p:cNvPr>
+          <p:cNvPicPr>
+            <a:picLocks noChangeAspect="1"/>
+          </p:cNvPicPr>
+          <p:nvPr/>
+        </p:nvPicPr>
+        <p:blipFill>
+          <a:blip r:embed="rId1"/>
+          <a:stretch>
+            <a:fillRect/>
+          </a:stretch>
+        </p:blipFill>
+        <p:spPr>
+          <a:xfrm>
+            <a:off x="0" y="658368"/>
+            <a:ext cx="5120640" cy="5833872"/>
+          </a:xfrm>
+          <a:prstGeom prst="rect">
+            <a:avLst/>
+          </a:prstGeom>
+        </p:spPr>
+      </p:pic>
+      <p:sp>
+        <p:nvSpPr>
+          <p:cNvPr id="4" name="Text 1"/>
+          <p:cNvSpPr/>
+          <p:nvPr/>
+        </p:nvSpPr>
+        <p:spPr>
+          <a:xfrm>
+            <a:off x="5349240" y="1005840"/>
+            <a:ext cx="6522415" cy="731520"/>
+          </a:xfrm>
+          <a:prstGeom prst="rect">
+            <a:avLst/>
+          </a:prstGeom>
+          <a:noFill/>
+          <a:ln/>
+        </p:spPr>
+        <p:txBody>
+          <a:bodyPr wrap="square" lIns="0" tIns="0" rIns="0" bIns="0" rtlCol="0" anchor="ctr">
+            <a:normAutofit/>
+          </a:bodyPr>
+          <a:lstStyle/>
+          <a:p>
+            <a:pPr algn="ctr" indent="0" marL="0">
+              <a:buNone/>
+            </a:pPr>
+            <a:r>
+              <a:rPr lang="en-US" sz="3600" b="1" dirty="0">
+                <a:solidFill>
+                  <a:srgbClr val="990011"/>
+                </a:solidFill>
+                <a:latin typeface="Times New Roman" pitchFamily="34" charset="0"/>
+                <a:ea typeface="Times New Roman" pitchFamily="34" charset="-122"/>
+                <a:cs typeface="Times New Roman" pitchFamily="34" charset="-120"/>
+              </a:rPr>
+              <a:t>Homework</a:t>
+            </a:r>
+            <a:endParaRPr lang="en-US" sz="3600" dirty="0"/>
+          </a:p>
+        </p:txBody>
+      </p:sp>
+      <p:sp>
+        <p:nvSpPr>
+          <p:cNvPr id="5" name="Text 2"/>
+          <p:cNvSpPr/>
+          <p:nvPr/>
+        </p:nvSpPr>
+        <p:spPr>
+          <a:xfrm>
+            <a:off x="5349240" y="1783080"/>
+            <a:ext cx="6522415" cy="4663440"/>
+          </a:xfrm>
+          <a:prstGeom prst="rect">
+            <a:avLst/>
+          </a:prstGeom>
+          <a:noFill/>
+          <a:ln/>
+        </p:spPr>
+        <p:txBody>
+          <a:bodyPr wrap="square" lIns="0" tIns="0" rIns="0" bIns="0" rtlCol="0" anchor="t"/>
+          <a:lstStyle/>
+          <a:p>
+            <a:pPr algn="l" indent="0" marL="0">
+              <a:spcAft>
+                <a:spcPts val="800"/>
+              </a:spcAft>
+              <a:buNone/>
+            </a:pPr>
+            <a:r>
+              <a:rPr lang="en-US" sz="4000" dirty="0">
+                <a:solidFill>
+                  <a:srgbClr val="111111"/>
+                </a:solidFill>
+                <a:latin typeface="Times New Roman" pitchFamily="34" charset="0"/>
+                <a:ea typeface="Times New Roman" pitchFamily="34" charset="-122"/>
+                <a:cs typeface="Times New Roman" pitchFamily="34" charset="-120"/>
+              </a:rPr>
+              <a:t>Collect three different stones or building materials (for example a piece of granite, a sandstone block and a piece of marble or tile). Write where you found each one.</a:t>
+            </a:r>
+            <a:endParaRPr lang="en-US" sz="4000" dirty="0"/>
+          </a:p>
+        </p:txBody>
+      </p:sp>
+      <p:sp>
+        <p:nvSpPr>
+          <p:cNvPr id="25" name="Slide Number Placeholder 0"/>
+          <p:cNvSpPr>
+            <a:spLocks noGrp="1"/>
+          </p:cNvSpPr>
+          <p:nvPr>
+            <p:ph type="sldNum" sz="quarter" idx="4294967295"/>
+          </p:nvPr>
+        </p:nvSpPr>
+        <p:spPr>
+          <a:xfrm>
+            <a:off x="27432" y="91440"/>
+            <a:ext cx="585216" cy="475488"/>
+          </a:xfrm>
+          <a:prstGeom prst="rect">
+            <a:avLst/>
+          </a:prstGeom>
+          <a:extLst>
+            <a:ext uri="{C572A759-6A51-4108-AA02-DFA0A04FC94B}">
+              <ma14:wrappingTextBoxFlag xmlns:ma14="http://schemas.microsoft.com/office/mac/drawingml/2011/main" val="0"/>
+            </a:ext>
+          </a:extLst>
+        </p:spPr>
+        <p:txBody>
+          <a:bodyPr/>
+          <a:lstStyle>
+            <a:lvl1pPr>
+              <a:defRPr sz="2000">
+                <a:solidFill>
+                  <a:srgbClr val="FFFFFF"/>
+                </a:solidFill>
+                <a:latin typeface="Calibri"/>
+                <a:ea typeface="Calibri"/>
+                <a:cs typeface="Calibri"/>
+              </a:defRPr>
+            </a:lvl1pPr>
+          </a:lstStyle>
+          <a:p>
+            <a:pPr algn="ctr"/>
+            <a:fld id="{F7021451-1387-4CA6-816F-3879F97B5CBC}" type="slidenum">
+              <a:rPr b="1" lang="en-US"/>
+              <a:t>43</a:t>
+            </a:fld>
+            <a:endParaRPr lang="en-US"/>
+          </a:p>
+        </p:txBody>
+      </p:sp>
+    </p:spTree>
+  </p:cSld>
+  <p:clrMapOvr>
+    <a:masterClrMapping/>
+  </p:clrMapOvr>
+</p:sld>
+</file>
+
+<file path=ppt/slides/slide44.xml><?xml version="1.0" encoding="utf-8"?>
+<p:sld xmlns:a="http://schemas.openxmlformats.org/drawingml/2006/main" xmlns:r="http://schemas.openxmlformats.org/officeDocument/2006/relationships" xmlns:p="http://schemas.openxmlformats.org/presentationml/2006/main">
+  <p:cSld name="Slide 44">
+    <p:spTree>
+      <p:nvGrpSpPr>
+        <p:cNvPr id="1" name=""/>
+        <p:cNvGrpSpPr/>
+        <p:nvPr/>
+      </p:nvGrpSpPr>
+      <p:grpSpPr>
+        <a:xfrm>
+          <a:off x="0" y="0"/>
+          <a:ext cx="0" cy="0"/>
+          <a:chOff x="0" y="0"/>
+          <a:chExt cx="0" cy="0"/>
+        </a:xfrm>
+      </p:grpSpPr>
+      <p:sp>
+        <p:nvSpPr>
+          <p:cNvPr id="2" name="Text 0"/>
+          <p:cNvSpPr/>
+          <p:nvPr/>
+        </p:nvSpPr>
+        <p:spPr>
+          <a:xfrm>
+            <a:off x="457200" y="713232"/>
+            <a:ext cx="11368735" cy="274320"/>
+          </a:xfrm>
+          <a:prstGeom prst="rect">
+            <a:avLst/>
+          </a:prstGeom>
+          <a:noFill/>
+          <a:ln/>
+        </p:spPr>
+        <p:txBody>
+          <a:bodyPr wrap="square" lIns="0" tIns="0" rIns="0" bIns="0" rtlCol="0" anchor="ctr"/>
+          <a:lstStyle/>
+          <a:p>
+            <a:pPr algn="r" indent="0" marL="0">
+              <a:buNone/>
+            </a:pPr>
+            <a:r>
+              <a:rPr lang="en-US" sz="1400" b="1" dirty="0">
+                <a:solidFill>
+                  <a:srgbClr val="1C3F6E"/>
+                </a:solidFill>
+                <a:latin typeface="Calibri" pitchFamily="34" charset="0"/>
+                <a:ea typeface="Calibri" pitchFamily="34" charset="-122"/>
+                <a:cs typeface="Calibri" pitchFamily="34" charset="-120"/>
+              </a:rPr>
+              <a:t>NEXT LESSON</a:t>
+            </a:r>
+            <a:endParaRPr lang="en-US" sz="1400" dirty="0"/>
+          </a:p>
+        </p:txBody>
+      </p:sp>
+      <p:pic>
+        <p:nvPicPr>
+          <p:cNvPr id="3" name="Image 0" descr="/home/claude/f4/img/minesec_sheet.png">    </p:cNvPr>
+          <p:cNvPicPr>
+            <a:picLocks noChangeAspect="1"/>
+          </p:cNvPicPr>
+          <p:nvPr/>
+        </p:nvPicPr>
+        <p:blipFill>
+          <a:blip r:embed="rId1"/>
+          <a:stretch>
+            <a:fillRect/>
+          </a:stretch>
+        </p:blipFill>
+        <p:spPr>
+          <a:xfrm>
+            <a:off x="0" y="658368"/>
+            <a:ext cx="5120640" cy="5833872"/>
+          </a:xfrm>
+          <a:prstGeom prst="rect">
+            <a:avLst/>
+          </a:prstGeom>
+        </p:spPr>
+      </p:pic>
+      <p:sp>
+        <p:nvSpPr>
+          <p:cNvPr id="4" name="Text 1"/>
+          <p:cNvSpPr/>
+          <p:nvPr/>
+        </p:nvSpPr>
+        <p:spPr>
+          <a:xfrm>
+            <a:off x="5349240" y="1005840"/>
+            <a:ext cx="6522415" cy="731520"/>
+          </a:xfrm>
+          <a:prstGeom prst="rect">
+            <a:avLst/>
+          </a:prstGeom>
+          <a:noFill/>
+          <a:ln/>
+        </p:spPr>
+        <p:txBody>
+          <a:bodyPr wrap="square" lIns="0" tIns="0" rIns="0" bIns="0" rtlCol="0" anchor="ctr">
+            <a:normAutofit/>
+          </a:bodyPr>
+          <a:lstStyle/>
+          <a:p>
+            <a:pPr algn="ctr" indent="0" marL="0">
+              <a:buNone/>
+            </a:pPr>
+            <a:r>
+              <a:rPr lang="en-US" sz="3600" b="1" dirty="0">
+                <a:solidFill>
+                  <a:srgbClr val="990011"/>
+                </a:solidFill>
+                <a:latin typeface="Times New Roman" pitchFamily="34" charset="0"/>
+                <a:ea typeface="Times New Roman" pitchFamily="34" charset="-122"/>
+                <a:cs typeface="Times New Roman" pitchFamily="34" charset="-120"/>
+              </a:rPr>
+              <a:t>Next Lesson</a:t>
+            </a:r>
+            <a:endParaRPr lang="en-US" sz="3600" dirty="0"/>
+          </a:p>
+        </p:txBody>
+      </p:sp>
+      <p:sp>
+        <p:nvSpPr>
+          <p:cNvPr id="5" name="Text 2"/>
+          <p:cNvSpPr/>
+          <p:nvPr/>
+        </p:nvSpPr>
+        <p:spPr>
+          <a:xfrm>
+            <a:off x="5349240" y="1783080"/>
+            <a:ext cx="6522415" cy="4663440"/>
+          </a:xfrm>
+          <a:prstGeom prst="rect">
+            <a:avLst/>
+          </a:prstGeom>
+          <a:noFill/>
+          <a:ln/>
+        </p:spPr>
+        <p:txBody>
+          <a:bodyPr wrap="square" lIns="0" tIns="0" rIns="0" bIns="0" rtlCol="0" anchor="ctr"/>
+          <a:lstStyle/>
+          <a:p>
+            <a:pPr algn="ctr" indent="0" marL="0">
+              <a:spcAft>
+                <a:spcPts val="800"/>
+              </a:spcAft>
+              <a:buNone/>
+            </a:pPr>
+            <a:r>
+              <a:rPr lang="en-US" sz="4000" b="1" dirty="0">
+                <a:solidFill>
+                  <a:srgbClr val="111111"/>
+                </a:solidFill>
+                <a:latin typeface="Times New Roman" pitchFamily="34" charset="0"/>
+                <a:ea typeface="Times New Roman" pitchFamily="34" charset="-122"/>
+                <a:cs typeface="Times New Roman" pitchFamily="34" charset="-120"/>
+              </a:rPr>
+              <a:t>Our next lesson will be on:</a:t>
+            </a:r>
+            <a:endParaRPr lang="en-US" sz="4000" dirty="0"/>
+          </a:p>
+          <a:p>
+            <a:pPr algn="ctr" indent="0" marL="0">
+              <a:spcAft>
+                <a:spcPts val="800"/>
+              </a:spcAft>
+              <a:buNone/>
+            </a:pPr>
+            <a:r>
+              <a:rPr lang="en-US" sz="4000" b="1" dirty="0">
+                <a:solidFill>
+                  <a:srgbClr val="990011"/>
+                </a:solidFill>
+                <a:latin typeface="Times New Roman" pitchFamily="34" charset="0"/>
+                <a:ea typeface="Times New Roman" pitchFamily="34" charset="-122"/>
+                <a:cs typeface="Times New Roman" pitchFamily="34" charset="-120"/>
+              </a:rPr>
+              <a:t>Lesson 8: Rocks</a:t>
+            </a:r>
+            <a:endParaRPr lang="en-US" sz="4000" dirty="0"/>
+          </a:p>
+        </p:txBody>
+      </p:sp>
+      <p:sp>
+        <p:nvSpPr>
+          <p:cNvPr id="25" name="Slide Number Placeholder 0"/>
+          <p:cNvSpPr>
+            <a:spLocks noGrp="1"/>
+          </p:cNvSpPr>
+          <p:nvPr>
+            <p:ph type="sldNum" sz="quarter" idx="4294967295"/>
+          </p:nvPr>
+        </p:nvSpPr>
+        <p:spPr>
+          <a:xfrm>
+            <a:off x="27432" y="91440"/>
+            <a:ext cx="585216" cy="475488"/>
+          </a:xfrm>
+          <a:prstGeom prst="rect">
+            <a:avLst/>
+          </a:prstGeom>
+          <a:extLst>
+            <a:ext uri="{C572A759-6A51-4108-AA02-DFA0A04FC94B}">
+              <ma14:wrappingTextBoxFlag xmlns:ma14="http://schemas.microsoft.com/office/mac/drawingml/2011/main" val="0"/>
+            </a:ext>
+          </a:extLst>
+        </p:spPr>
+        <p:txBody>
+          <a:bodyPr/>
+          <a:lstStyle>
+            <a:lvl1pPr>
+              <a:defRPr sz="2000">
+                <a:solidFill>
+                  <a:srgbClr val="FFFFFF"/>
+                </a:solidFill>
+                <a:latin typeface="Calibri"/>
+                <a:ea typeface="Calibri"/>
+                <a:cs typeface="Calibri"/>
+              </a:defRPr>
+            </a:lvl1pPr>
+          </a:lstStyle>
+          <a:p>
+            <a:pPr algn="ctr"/>
+            <a:fld id="{F7021451-1387-4CA6-816F-3879F97B5CBC}" type="slidenum">
+              <a:rPr b="1" lang="en-US"/>
+              <a:t>44</a:t>
+            </a:fld>
+            <a:endParaRPr lang="en-US"/>
+          </a:p>
+        </p:txBody>
+      </p:sp>
+    </p:spTree>
+  </p:cSld>
+  <p:clrMapOvr>
+    <a:masterClrMapping/>
+  </p:clrMapOvr>
+</p:sld>
+</file>
+
+<file path=ppt/slides/slide45.xml><?xml version="1.0" encoding="utf-8"?>
+<p:sld xmlns:a="http://schemas.openxmlformats.org/drawingml/2006/main" xmlns:r="http://schemas.openxmlformats.org/officeDocument/2006/relationships" xmlns:p="http://schemas.openxmlformats.org/presentationml/2006/main">
+  <p:cSld name="Slide 45">
+    <p:spTree>
+      <p:nvGrpSpPr>
+        <p:cNvPr id="1" name=""/>
+        <p:cNvGrpSpPr/>
+        <p:nvPr/>
+      </p:nvGrpSpPr>
+      <p:grpSpPr>
+        <a:xfrm>
+          <a:off x="0" y="0"/>
+          <a:ext cx="0" cy="0"/>
+          <a:chOff x="0" y="0"/>
+          <a:chExt cx="0" cy="0"/>
+        </a:xfrm>
+      </p:grpSpPr>
+      <p:sp>
+        <p:nvSpPr>
+          <p:cNvPr id="2" name="Text 0"/>
+          <p:cNvSpPr/>
+          <p:nvPr/>
+        </p:nvSpPr>
+        <p:spPr>
+          <a:xfrm>
+            <a:off x="457200" y="713232"/>
+            <a:ext cx="11368735" cy="274320"/>
+          </a:xfrm>
+          <a:prstGeom prst="rect">
+            <a:avLst/>
+          </a:prstGeom>
+          <a:noFill/>
+          <a:ln/>
+        </p:spPr>
+        <p:txBody>
+          <a:bodyPr wrap="square" lIns="0" tIns="0" rIns="0" bIns="0" rtlCol="0" anchor="ctr"/>
+          <a:lstStyle/>
+          <a:p>
+            <a:pPr algn="r" indent="0" marL="0">
+              <a:buNone/>
+            </a:pPr>
+            <a:r>
+              <a:rPr lang="en-US" sz="1400" b="1" dirty="0">
+                <a:solidFill>
+                  <a:srgbClr val="1C3F6E"/>
+                </a:solidFill>
+                <a:latin typeface="Calibri" pitchFamily="34" charset="0"/>
+                <a:ea typeface="Calibri" pitchFamily="34" charset="-122"/>
+                <a:cs typeface="Calibri" pitchFamily="34" charset="-120"/>
+              </a:rPr>
               <a:t>BILINGUAL GAME</a:t>
             </a:r>
             <a:endParaRPr lang="en-US" sz="1400" dirty="0"/>
@@ -14742,7 +16167,7 @@
       </p:sp>
       <p:graphicFrame>
         <p:nvGraphicFramePr>
-          <p:cNvPr id="42" name="Table 0"/>
+          <p:cNvPr id="46" name="Table 0"/>
           <p:cNvGraphicFramePr>
             <a:graphicFrameLocks noGrp="1"/>
           </p:cNvGraphicFramePr>
@@ -16054,7 +17479,7 @@
             <a:pPr algn="ctr"/>
             <a:fld id="{F7021451-1387-4CA6-816F-3879F97B5CBC}" type="slidenum">
               <a:rPr b="1" lang="en-US"/>
-              <a:t>41</a:t>
+              <a:t>45</a:t>
             </a:fld>
             <a:endParaRPr lang="en-US"/>
           </a:p>
@@ -16068,9 +17493,9 @@
 </p:sld>
 </file>
 
-<file path=ppt/slides/slide42.xml><?xml version="1.0" encoding="utf-8"?>
+<file path=ppt/slides/slide46.xml><?xml version="1.0" encoding="utf-8"?>
 <p:sld xmlns:a="http://schemas.openxmlformats.org/drawingml/2006/main" xmlns:r="http://schemas.openxmlformats.org/officeDocument/2006/relationships" xmlns:p="http://schemas.openxmlformats.org/presentationml/2006/main">
-  <p:cSld name="Slide 42">
+  <p:cSld name="Slide 46">
     <p:spTree>
       <p:nvGrpSpPr>
         <p:cNvPr id="1" name=""/>
@@ -16165,7 +17590,7 @@
       </p:sp>
       <p:graphicFrame>
         <p:nvGraphicFramePr>
-          <p:cNvPr id="43" name="Table 0"/>
+          <p:cNvPr id="47" name="Table 0"/>
           <p:cNvGraphicFramePr>
             <a:graphicFrameLocks noGrp="1"/>
           </p:cNvGraphicFramePr>
@@ -16787,7 +18212,7 @@
             <a:pPr algn="ctr"/>
             <a:fld id="{F7021451-1387-4CA6-816F-3879F97B5CBC}" type="slidenum">
               <a:rPr b="1" lang="en-US"/>
-              <a:t>42</a:t>
+              <a:t>46</a:t>
             </a:fld>
             <a:endParaRPr lang="en-US"/>
           </a:p>
@@ -16801,9 +18226,9 @@
 </p:sld>
 </file>
 
-<file path=ppt/slides/slide43.xml><?xml version="1.0" encoding="utf-8"?>
+<file path=ppt/slides/slide47.xml><?xml version="1.0" encoding="utf-8"?>
 <p:sld xmlns:a="http://schemas.openxmlformats.org/drawingml/2006/main" xmlns:r="http://schemas.openxmlformats.org/officeDocument/2006/relationships" xmlns:p="http://schemas.openxmlformats.org/presentationml/2006/main">
-  <p:cSld name="Slide 43">
+  <p:cSld name="Slide 47">
     <p:spTree>
       <p:nvGrpSpPr>
         <p:cNvPr id="1" name=""/>
@@ -16898,7 +18323,7 @@
       </p:sp>
       <p:graphicFrame>
         <p:nvGraphicFramePr>
-          <p:cNvPr id="44" name="Table 0"/>
+          <p:cNvPr id="48" name="Table 0"/>
           <p:cNvGraphicFramePr>
             <a:graphicFrameLocks noGrp="1"/>
           </p:cNvGraphicFramePr>
@@ -17008,7 +18433,7 @@
                           <a:ea typeface="Calibri" pitchFamily="34" charset="-122"/>
                           <a:cs typeface="Calibri" pitchFamily="34" charset="-120"/>
                         </a:rPr>
-                        <a:t>Illustration of the Structure of the Earth; The Main Layers.</a:t>
+                        <a:t>DEFINITIONS; Illustrations of the Structure of the Earth; Brief Description of the Main Layers.</a:t>
                       </a:r>
                       <a:endParaRPr lang="en-US" sz="1600" dirty="0">
                         <a:latin typeface="Calibri" charset="0"/>
@@ -17658,7 +19083,7 @@
             <a:pPr algn="ctr"/>
             <a:fld id="{F7021451-1387-4CA6-816F-3879F97B5CBC}" type="slidenum">
               <a:rPr b="1" lang="en-US"/>
-              <a:t>43</a:t>
+              <a:t>47</a:t>
             </a:fld>
             <a:endParaRPr lang="en-US"/>
           </a:p>
@@ -17672,9 +19097,9 @@
 </p:sld>
 </file>
 
-<file path=ppt/slides/slide44.xml><?xml version="1.0" encoding="utf-8"?>
+<file path=ppt/slides/slide48.xml><?xml version="1.0" encoding="utf-8"?>
 <p:sld xmlns:a="http://schemas.openxmlformats.org/drawingml/2006/main" xmlns:r="http://schemas.openxmlformats.org/officeDocument/2006/relationships" xmlns:p="http://schemas.openxmlformats.org/presentationml/2006/main">
-  <p:cSld name="Slide 44">
+  <p:cSld name="Slide 48">
     <p:spTree>
       <p:nvGrpSpPr>
         <p:cNvPr id="1" name=""/>
@@ -17872,7 +19297,7 @@
                 <a:ea typeface="Calibri" pitchFamily="34" charset="-122"/>
                 <a:cs typeface="Calibri" pitchFamily="34" charset="-120"/>
               </a:rPr>
-              <a:t>Without the projector (Activity 1): ask learners how deep the wells of their area are.</a:t>
+              <a:t>Without the projector (Activity 1): cut a boiled egg or an onion: shell, white, yolk.</a:t>
             </a:r>
             <a:endParaRPr lang="en-US" sz="2000" dirty="0"/>
           </a:p>
@@ -17893,7 +19318,7 @@
                 <a:ea typeface="Calibri" pitchFamily="34" charset="-122"/>
                 <a:cs typeface="Calibri" pitchFamily="34" charset="-120"/>
               </a:rPr>
-              <a:t>Without the projector (Activity 2): cut a boiled egg or an onion: shell, white, yolk.</a:t>
+              <a:t>Without the projector (Activity 2): ask learners how deep the wells of their area are.</a:t>
             </a:r>
             <a:endParaRPr lang="en-US" sz="2000" dirty="0"/>
           </a:p>
@@ -17962,7 +19387,7 @@
             <a:pPr algn="ctr"/>
             <a:fld id="{F7021451-1387-4CA6-816F-3879F97B5CBC}" type="slidenum">
               <a:rPr b="1" lang="en-US"/>
-              <a:t>44</a:t>
+              <a:t>48</a:t>
             </a:fld>
             <a:endParaRPr lang="en-US"/>
           </a:p>
@@ -17976,9 +19401,9 @@
 </p:sld>
 </file>
 
-<file path=ppt/slides/slide45.xml><?xml version="1.0" encoding="utf-8"?>
+<file path=ppt/slides/slide49.xml><?xml version="1.0" encoding="utf-8"?>
 <p:sld xmlns:a="http://schemas.openxmlformats.org/drawingml/2006/main" xmlns:r="http://schemas.openxmlformats.org/officeDocument/2006/relationships" xmlns:p="http://schemas.openxmlformats.org/presentationml/2006/main">
-  <p:cSld name="Slide 45">
+  <p:cSld name="Slide 49">
     <p:spTree>
       <p:nvGrpSpPr>
         <p:cNvPr id="1" name=""/>
@@ -18176,7 +19601,7 @@
                 <a:ea typeface="Calibri" pitchFamily="34" charset="-122"/>
                 <a:cs typeface="Calibri" pitchFamily="34" charset="-120"/>
               </a:rPr>
-              <a:t>Photo, Activity 1: “Laterite soil bricks in Richard Rebello's farm” by India Water Portal, CC BY-NC-SA 2.0, via Flickr (https://www.flickr.com/photos/21623815@N03/10720461943)</a:t>
+              <a:t>Photo, Activity 2: “Laterite soil bricks in Richard Rebello's farm” by India Water Portal, CC BY-NC-SA 2.0, via Flickr (https://www.flickr.com/photos/21623815@N03/10720461943)</a:t>
             </a:r>
             <a:endParaRPr lang="en-US" sz="1800" dirty="0"/>
           </a:p>
@@ -18245,7 +19670,7 @@
             <a:pPr algn="ctr"/>
             <a:fld id="{F7021451-1387-4CA6-816F-3879F97B5CBC}" type="slidenum">
               <a:rPr b="1" lang="en-US"/>
-              <a:t>45</a:t>
+              <a:t>49</a:t>
             </a:fld>
             <a:endParaRPr lang="en-US"/>
           </a:p>

</xml_diff>